<commit_message>
docs: update presentation file
</commit_message>
<xml_diff>
--- a/Renai-Hospital_PresentationV4_final.pptx
+++ b/Renai-Hospital_PresentationV4_final.pptx
@@ -2826,11 +2826,8 @@
           <a:bodyPr wrap="square" lIns="0" tIns="0" rIns="0" bIns="0" rtlCol="0" anchor="ctr"/>
           <a:lstStyle/>
           <a:p>
-            <a:pPr marL="0" indent="0" algn="l">
-              <a:buNone/>
-            </a:pPr>
-            <a:r>
-              <a:rPr lang="en-US" sz="1200" dirty="0">
+            <a:r>
+              <a:rPr lang="en-US" altLang="zh-TW" sz="1200" dirty="0" err="1">
                 <a:solidFill>
                   <a:srgbClr val="1A202C"/>
                 </a:solidFill>
@@ -2838,36 +2835,11 @@
                 <a:ea typeface="Calibri" pitchFamily="34" charset="-122"/>
                 <a:cs typeface="Calibri" pitchFamily="34" charset="-120"/>
               </a:rPr>
-              <a:t>預訓練 ImageNet 權重 (Transfer Learning)</a:t>
-            </a:r>
-            <a:endParaRPr lang="en-US" sz="1200" dirty="0"/>
-          </a:p>
-        </p:txBody>
-      </p:sp>
-      <p:sp>
-        <p:nvSpPr>
-          <p:cNvPr id="16" name="Shape 14"/>
-          <p:cNvSpPr/>
-          <p:nvPr/>
-        </p:nvSpPr>
-        <p:spPr>
-          <a:xfrm>
-            <a:off x="502920" y="3730752"/>
-            <a:ext cx="164592" cy="164592"/>
-          </a:xfrm>
-          <a:prstGeom prst="ellipse">
-            <a:avLst/>
-          </a:prstGeom>
-          <a:solidFill>
-            <a:srgbClr val="065A82"/>
-          </a:solidFill>
-          <a:ln w="12700">
-            <a:solidFill>
-              <a:srgbClr val="065A82"/>
-            </a:solidFill>
-            <a:prstDash val="solid"/>
-          </a:ln>
-        </p:spPr>
+              <a:t>最終層替換為二元分類頭</a:t>
+            </a:r>
+            <a:endParaRPr lang="en-US" altLang="zh-TW" sz="1200" dirty="0"/>
+          </a:p>
+        </p:txBody>
       </p:sp>
       <p:sp>
         <p:nvSpPr>
@@ -2893,17 +2865,6 @@
             <a:pPr marL="0" indent="0" algn="l">
               <a:buNone/>
             </a:pPr>
-            <a:r>
-              <a:rPr lang="en-US" sz="1200" dirty="0">
-                <a:solidFill>
-                  <a:srgbClr val="1A202C"/>
-                </a:solidFill>
-                <a:latin typeface="Calibri" pitchFamily="34" charset="0"/>
-                <a:ea typeface="Calibri" pitchFamily="34" charset="-122"/>
-                <a:cs typeface="Calibri" pitchFamily="34" charset="-120"/>
-              </a:rPr>
-              <a:t>最終層替換為二元分類頭</a:t>
-            </a:r>
             <a:endParaRPr lang="en-US" sz="1200" dirty="0"/>
           </a:p>
         </p:txBody>
@@ -4571,7 +4532,7 @@
               <a:buNone/>
             </a:pPr>
             <a:r>
-              <a:rPr lang="en-US" sz="1800" b="1" dirty="0">
+              <a:rPr lang="en-US" sz="1800" b="1" dirty="0" err="1">
                 <a:solidFill>
                   <a:srgbClr val="FFFFFF"/>
                 </a:solidFill>
@@ -4579,7 +4540,7 @@
                 <a:ea typeface="Calibri" pitchFamily="34" charset="-122"/>
                 <a:cs typeface="Calibri" pitchFamily="34" charset="-120"/>
               </a:rPr>
-              <a:t>端對端系統實驗結果</a:t>
+              <a:t>系統實驗結果</a:t>
             </a:r>
             <a:endParaRPr lang="en-US" sz="1800" dirty="0"/>
           </a:p>
@@ -4781,7 +4742,7 @@
         </p:nvSpPr>
         <p:spPr>
           <a:xfrm>
-            <a:off x="1746504" y="594360"/>
+            <a:off x="3181858" y="594360"/>
             <a:ext cx="1325880" cy="1051560"/>
           </a:xfrm>
           <a:prstGeom prst="rect">
@@ -4813,7 +4774,7 @@
         </p:nvSpPr>
         <p:spPr>
           <a:xfrm>
-            <a:off x="1746504" y="621792"/>
+            <a:off x="3181858" y="621792"/>
             <a:ext cx="1325880" cy="594360"/>
           </a:xfrm>
           <a:prstGeom prst="rect">
@@ -4852,7 +4813,7 @@
         </p:nvSpPr>
         <p:spPr>
           <a:xfrm>
-            <a:off x="1750314" y="1213104"/>
+            <a:off x="3185668" y="1213104"/>
             <a:ext cx="1325880" cy="228600"/>
           </a:xfrm>
           <a:prstGeom prst="rect">
@@ -4891,7 +4852,7 @@
         </p:nvSpPr>
         <p:spPr>
           <a:xfrm>
-            <a:off x="1742694" y="1441704"/>
+            <a:off x="3178048" y="1441704"/>
             <a:ext cx="1325880" cy="201168"/>
           </a:xfrm>
           <a:prstGeom prst="rect">
@@ -4930,7 +4891,7 @@
         </p:nvSpPr>
         <p:spPr>
           <a:xfrm>
-            <a:off x="3172968" y="594360"/>
+            <a:off x="4608322" y="594360"/>
             <a:ext cx="1325880" cy="1051560"/>
           </a:xfrm>
           <a:prstGeom prst="rect">
@@ -4962,7 +4923,7 @@
         </p:nvSpPr>
         <p:spPr>
           <a:xfrm>
-            <a:off x="3172968" y="621792"/>
+            <a:off x="4608322" y="621792"/>
             <a:ext cx="1325880" cy="594360"/>
           </a:xfrm>
           <a:prstGeom prst="rect">
@@ -5001,7 +4962,7 @@
         </p:nvSpPr>
         <p:spPr>
           <a:xfrm>
-            <a:off x="3172968" y="1207008"/>
+            <a:off x="4608322" y="1207008"/>
             <a:ext cx="1325880" cy="228600"/>
           </a:xfrm>
           <a:prstGeom prst="rect">
@@ -5040,7 +5001,7 @@
         </p:nvSpPr>
         <p:spPr>
           <a:xfrm>
-            <a:off x="3165348" y="1453896"/>
+            <a:off x="4600702" y="1453896"/>
             <a:ext cx="1325880" cy="201168"/>
           </a:xfrm>
           <a:prstGeom prst="rect">
@@ -5079,7 +5040,7 @@
         </p:nvSpPr>
         <p:spPr>
           <a:xfrm>
-            <a:off x="4599432" y="594360"/>
+            <a:off x="1749044" y="594360"/>
             <a:ext cx="1325880" cy="1051560"/>
           </a:xfrm>
           <a:prstGeom prst="rect">
@@ -5111,7 +5072,7 @@
         </p:nvSpPr>
         <p:spPr>
           <a:xfrm>
-            <a:off x="4599432" y="621792"/>
+            <a:off x="1749044" y="621792"/>
             <a:ext cx="1325880" cy="594360"/>
           </a:xfrm>
           <a:prstGeom prst="rect">
@@ -5150,7 +5111,7 @@
         </p:nvSpPr>
         <p:spPr>
           <a:xfrm>
-            <a:off x="4593082" y="1213104"/>
+            <a:off x="1742694" y="1213104"/>
             <a:ext cx="1325880" cy="228600"/>
           </a:xfrm>
           <a:prstGeom prst="rect">
@@ -5189,7 +5150,7 @@
         </p:nvSpPr>
         <p:spPr>
           <a:xfrm>
-            <a:off x="4593082" y="1435608"/>
+            <a:off x="1742694" y="1435608"/>
             <a:ext cx="1325880" cy="201168"/>
           </a:xfrm>
           <a:prstGeom prst="rect">
@@ -5229,7 +5190,7 @@
         <p:spPr>
           <a:xfrm>
             <a:off x="320040" y="1764792"/>
-            <a:ext cx="4297680" cy="292608"/>
+            <a:ext cx="2245451" cy="292608"/>
           </a:xfrm>
           <a:prstGeom prst="rect">
             <a:avLst/>
@@ -5253,7 +5214,40 @@
                 <a:ea typeface="Calibri" pitchFamily="34" charset="-122"/>
                 <a:cs typeface="Calibri" pitchFamily="34" charset="-120"/>
               </a:rPr>
-              <a:t>各期別效能（Test set，Hierarchical 系統）</a:t>
+              <a:t>各</a:t>
+            </a:r>
+            <a:r>
+              <a:rPr lang="zh-TW" altLang="en-US" sz="1200" b="1" dirty="0">
+                <a:solidFill>
+                  <a:srgbClr val="065A82"/>
+                </a:solidFill>
+                <a:latin typeface="Calibri" pitchFamily="34" charset="0"/>
+                <a:ea typeface="Calibri" pitchFamily="34" charset="-122"/>
+                <a:cs typeface="Calibri" pitchFamily="34" charset="-120"/>
+              </a:rPr>
+              <a:t>級</a:t>
+            </a:r>
+            <a:r>
+              <a:rPr lang="en-US" sz="1200" b="1" dirty="0" err="1">
+                <a:solidFill>
+                  <a:srgbClr val="065A82"/>
+                </a:solidFill>
+                <a:latin typeface="Calibri" pitchFamily="34" charset="0"/>
+                <a:ea typeface="Calibri" pitchFamily="34" charset="-122"/>
+                <a:cs typeface="Calibri" pitchFamily="34" charset="-120"/>
+              </a:rPr>
+              <a:t>別效能（Hierarchical</a:t>
+            </a:r>
+            <a:r>
+              <a:rPr lang="en-US" sz="1200" b="1" dirty="0">
+                <a:solidFill>
+                  <a:srgbClr val="065A82"/>
+                </a:solidFill>
+                <a:latin typeface="Calibri" pitchFamily="34" charset="0"/>
+                <a:ea typeface="Calibri" pitchFamily="34" charset="-122"/>
+                <a:cs typeface="Calibri" pitchFamily="34" charset="-120"/>
+              </a:rPr>
+              <a:t> 系統）</a:t>
             </a:r>
             <a:endParaRPr lang="en-US" sz="1200" dirty="0"/>
           </a:p>
@@ -5261,14 +5255,42 @@
       </p:sp>
       <p:sp>
         <p:nvSpPr>
-          <p:cNvPr id="22" name="Shape 20"/>
-          <p:cNvSpPr/>
-          <p:nvPr/>
-        </p:nvSpPr>
-        <p:spPr>
-          <a:xfrm>
-            <a:off x="320040" y="2121408"/>
-            <a:ext cx="685800" cy="274320"/>
+          <p:cNvPr id="23" name="Text 21"/>
+          <p:cNvSpPr/>
+          <p:nvPr/>
+        </p:nvSpPr>
+        <p:spPr>
+          <a:xfrm>
+            <a:off x="6172200" y="2027643"/>
+            <a:ext cx="685800" cy="273688"/>
+          </a:xfrm>
+          <a:prstGeom prst="rect">
+            <a:avLst/>
+          </a:prstGeom>
+          <a:noFill/>
+          <a:ln/>
+        </p:spPr>
+        <p:txBody>
+          <a:bodyPr wrap="square" lIns="0" tIns="0" rIns="0" bIns="0" rtlCol="0" anchor="ctr"/>
+          <a:lstStyle/>
+          <a:p>
+            <a:pPr marL="0" indent="0" algn="ctr">
+              <a:buNone/>
+            </a:pPr>
+            <a:endParaRPr lang="en-US" sz="1000" dirty="0"/>
+          </a:p>
+        </p:txBody>
+      </p:sp>
+      <p:sp>
+        <p:nvSpPr>
+          <p:cNvPr id="24" name="Shape 22"/>
+          <p:cNvSpPr/>
+          <p:nvPr/>
+        </p:nvSpPr>
+        <p:spPr>
+          <a:xfrm>
+            <a:off x="6858000" y="2027011"/>
+            <a:ext cx="822960" cy="274320"/>
           </a:xfrm>
           <a:prstGeom prst="rect">
             <a:avLst/>
@@ -5286,42 +5308,53 @@
       </p:sp>
       <p:sp>
         <p:nvSpPr>
-          <p:cNvPr id="23" name="Text 21"/>
-          <p:cNvSpPr/>
-          <p:nvPr/>
-        </p:nvSpPr>
-        <p:spPr>
-          <a:xfrm>
-            <a:off x="320040" y="2121408"/>
+          <p:cNvPr id="25" name="Text 23"/>
+          <p:cNvSpPr/>
+          <p:nvPr/>
+        </p:nvSpPr>
+        <p:spPr>
+          <a:xfrm>
+            <a:off x="6858000" y="2027011"/>
+            <a:ext cx="822960" cy="274320"/>
+          </a:xfrm>
+          <a:prstGeom prst="rect">
+            <a:avLst/>
+          </a:prstGeom>
+          <a:noFill/>
+          <a:ln/>
+        </p:spPr>
+        <p:txBody>
+          <a:bodyPr wrap="square" lIns="0" tIns="0" rIns="0" bIns="0" rtlCol="0" anchor="ctr"/>
+          <a:lstStyle/>
+          <a:p>
+            <a:pPr marL="0" indent="0" algn="ctr">
+              <a:buNone/>
+            </a:pPr>
+            <a:r>
+              <a:rPr lang="en-US" sz="1000" b="1" dirty="0">
+                <a:solidFill>
+                  <a:srgbClr val="FFFFFF"/>
+                </a:solidFill>
+                <a:latin typeface="Calibri" pitchFamily="34" charset="0"/>
+                <a:ea typeface="Calibri" pitchFamily="34" charset="-122"/>
+                <a:cs typeface="Calibri" pitchFamily="34" charset="-120"/>
+              </a:rPr>
+              <a:t>Precision</a:t>
+            </a:r>
+            <a:endParaRPr lang="en-US" sz="1000" dirty="0"/>
+          </a:p>
+        </p:txBody>
+      </p:sp>
+      <p:sp>
+        <p:nvSpPr>
+          <p:cNvPr id="26" name="Shape 24"/>
+          <p:cNvSpPr/>
+          <p:nvPr/>
+        </p:nvSpPr>
+        <p:spPr>
+          <a:xfrm>
+            <a:off x="7680960" y="2027011"/>
             <a:ext cx="685800" cy="274320"/>
-          </a:xfrm>
-          <a:prstGeom prst="rect">
-            <a:avLst/>
-          </a:prstGeom>
-          <a:noFill/>
-          <a:ln/>
-        </p:spPr>
-        <p:txBody>
-          <a:bodyPr wrap="square" lIns="0" tIns="0" rIns="0" bIns="0" rtlCol="0" anchor="ctr"/>
-          <a:lstStyle/>
-          <a:p>
-            <a:pPr marL="0" indent="0" algn="ctr">
-              <a:buNone/>
-            </a:pPr>
-            <a:endParaRPr lang="en-US" sz="1000" dirty="0"/>
-          </a:p>
-        </p:txBody>
-      </p:sp>
-      <p:sp>
-        <p:nvSpPr>
-          <p:cNvPr id="24" name="Shape 22"/>
-          <p:cNvSpPr/>
-          <p:nvPr/>
-        </p:nvSpPr>
-        <p:spPr>
-          <a:xfrm>
-            <a:off x="1005840" y="2121408"/>
-            <a:ext cx="822960" cy="274320"/>
           </a:xfrm>
           <a:prstGeom prst="rect">
             <a:avLst/>
@@ -5339,14 +5372,14 @@
       </p:sp>
       <p:sp>
         <p:nvSpPr>
-          <p:cNvPr id="25" name="Text 23"/>
-          <p:cNvSpPr/>
-          <p:nvPr/>
-        </p:nvSpPr>
-        <p:spPr>
-          <a:xfrm>
-            <a:off x="1005840" y="2121408"/>
-            <a:ext cx="822960" cy="274320"/>
+          <p:cNvPr id="27" name="Text 25"/>
+          <p:cNvSpPr/>
+          <p:nvPr/>
+        </p:nvSpPr>
+        <p:spPr>
+          <a:xfrm>
+            <a:off x="7680960" y="2027011"/>
+            <a:ext cx="685800" cy="274320"/>
           </a:xfrm>
           <a:prstGeom prst="rect">
             <a:avLst/>
@@ -5370,7 +5403,7 @@
                 <a:ea typeface="Calibri" pitchFamily="34" charset="-122"/>
                 <a:cs typeface="Calibri" pitchFamily="34" charset="-120"/>
               </a:rPr>
-              <a:t>Precision</a:t>
+              <a:t>Recall</a:t>
             </a:r>
             <a:endParaRPr lang="en-US" sz="1000" dirty="0"/>
           </a:p>
@@ -5378,13 +5411,13 @@
       </p:sp>
       <p:sp>
         <p:nvSpPr>
-          <p:cNvPr id="26" name="Shape 24"/>
-          <p:cNvSpPr/>
-          <p:nvPr/>
-        </p:nvSpPr>
-        <p:spPr>
-          <a:xfrm>
-            <a:off x="1828800" y="2121408"/>
+          <p:cNvPr id="30" name="Shape 28"/>
+          <p:cNvSpPr/>
+          <p:nvPr/>
+        </p:nvSpPr>
+        <p:spPr>
+          <a:xfrm>
+            <a:off x="8366760" y="2027011"/>
             <a:ext cx="685800" cy="274320"/>
           </a:xfrm>
           <a:prstGeom prst="rect">
@@ -5403,13 +5436,13 @@
       </p:sp>
       <p:sp>
         <p:nvSpPr>
-          <p:cNvPr id="27" name="Text 25"/>
-          <p:cNvSpPr/>
-          <p:nvPr/>
-        </p:nvSpPr>
-        <p:spPr>
-          <a:xfrm>
-            <a:off x="1828800" y="2121408"/>
+          <p:cNvPr id="31" name="Text 29"/>
+          <p:cNvSpPr/>
+          <p:nvPr/>
+        </p:nvSpPr>
+        <p:spPr>
+          <a:xfrm>
+            <a:off x="8366760" y="2027011"/>
             <a:ext cx="685800" cy="274320"/>
           </a:xfrm>
           <a:prstGeom prst="rect">
@@ -5434,7 +5467,7 @@
                 <a:ea typeface="Calibri" pitchFamily="34" charset="-122"/>
                 <a:cs typeface="Calibri" pitchFamily="34" charset="-120"/>
               </a:rPr>
-              <a:t>Recall</a:t>
+              <a:t>F1</a:t>
             </a:r>
             <a:endParaRPr lang="en-US" sz="1000" dirty="0"/>
           </a:p>
@@ -5442,142 +5475,14 @@
       </p:sp>
       <p:sp>
         <p:nvSpPr>
-          <p:cNvPr id="28" name="Shape 26"/>
-          <p:cNvSpPr/>
-          <p:nvPr/>
-        </p:nvSpPr>
-        <p:spPr>
-          <a:xfrm>
-            <a:off x="2514600" y="2121408"/>
-            <a:ext cx="914400" cy="274320"/>
-          </a:xfrm>
-          <a:prstGeom prst="rect">
-            <a:avLst/>
-          </a:prstGeom>
-          <a:solidFill>
-            <a:srgbClr val="0A2342"/>
-          </a:solidFill>
-          <a:ln w="12700">
-            <a:solidFill>
-              <a:srgbClr val="0A2342"/>
-            </a:solidFill>
-            <a:prstDash val="solid"/>
-          </a:ln>
-        </p:spPr>
-      </p:sp>
-      <p:sp>
-        <p:nvSpPr>
-          <p:cNvPr id="29" name="Text 27"/>
-          <p:cNvSpPr/>
-          <p:nvPr/>
-        </p:nvSpPr>
-        <p:spPr>
-          <a:xfrm>
-            <a:off x="2514600" y="2121408"/>
-            <a:ext cx="914400" cy="274320"/>
-          </a:xfrm>
-          <a:prstGeom prst="rect">
-            <a:avLst/>
-          </a:prstGeom>
-          <a:noFill/>
-          <a:ln/>
-        </p:spPr>
-        <p:txBody>
-          <a:bodyPr wrap="square" lIns="0" tIns="0" rIns="0" bIns="0" rtlCol="0" anchor="ctr"/>
-          <a:lstStyle/>
-          <a:p>
-            <a:pPr marL="0" indent="0" algn="ctr">
-              <a:buNone/>
-            </a:pPr>
-            <a:r>
-              <a:rPr lang="en-US" sz="1000" b="1" dirty="0">
-                <a:solidFill>
-                  <a:srgbClr val="FFFFFF"/>
-                </a:solidFill>
-                <a:latin typeface="Calibri" pitchFamily="34" charset="0"/>
-                <a:ea typeface="Calibri" pitchFamily="34" charset="-122"/>
-                <a:cs typeface="Calibri" pitchFamily="34" charset="-120"/>
-              </a:rPr>
-              <a:t>Specificity</a:t>
-            </a:r>
-            <a:endParaRPr lang="en-US" sz="1000" dirty="0"/>
-          </a:p>
-        </p:txBody>
-      </p:sp>
-      <p:sp>
-        <p:nvSpPr>
-          <p:cNvPr id="30" name="Shape 28"/>
-          <p:cNvSpPr/>
-          <p:nvPr/>
-        </p:nvSpPr>
-        <p:spPr>
-          <a:xfrm>
-            <a:off x="3429000" y="2121408"/>
-            <a:ext cx="685800" cy="274320"/>
-          </a:xfrm>
-          <a:prstGeom prst="rect">
-            <a:avLst/>
-          </a:prstGeom>
-          <a:solidFill>
-            <a:srgbClr val="0A2342"/>
-          </a:solidFill>
-          <a:ln w="12700">
-            <a:solidFill>
-              <a:srgbClr val="0A2342"/>
-            </a:solidFill>
-            <a:prstDash val="solid"/>
-          </a:ln>
-        </p:spPr>
-      </p:sp>
-      <p:sp>
-        <p:nvSpPr>
-          <p:cNvPr id="31" name="Text 29"/>
-          <p:cNvSpPr/>
-          <p:nvPr/>
-        </p:nvSpPr>
-        <p:spPr>
-          <a:xfrm>
-            <a:off x="3429000" y="2121408"/>
-            <a:ext cx="685800" cy="274320"/>
-          </a:xfrm>
-          <a:prstGeom prst="rect">
-            <a:avLst/>
-          </a:prstGeom>
-          <a:noFill/>
-          <a:ln/>
-        </p:spPr>
-        <p:txBody>
-          <a:bodyPr wrap="square" lIns="0" tIns="0" rIns="0" bIns="0" rtlCol="0" anchor="ctr"/>
-          <a:lstStyle/>
-          <a:p>
-            <a:pPr marL="0" indent="0" algn="ctr">
-              <a:buNone/>
-            </a:pPr>
-            <a:r>
-              <a:rPr lang="en-US" sz="1000" b="1" dirty="0">
-                <a:solidFill>
-                  <a:srgbClr val="FFFFFF"/>
-                </a:solidFill>
-                <a:latin typeface="Calibri" pitchFamily="34" charset="0"/>
-                <a:ea typeface="Calibri" pitchFamily="34" charset="-122"/>
-                <a:cs typeface="Calibri" pitchFamily="34" charset="-120"/>
-              </a:rPr>
-              <a:t>F1</a:t>
-            </a:r>
-            <a:endParaRPr lang="en-US" sz="1000" dirty="0"/>
-          </a:p>
-        </p:txBody>
-      </p:sp>
-      <p:sp>
-        <p:nvSpPr>
           <p:cNvPr id="32" name="Shape 30"/>
           <p:cNvSpPr/>
           <p:nvPr/>
         </p:nvSpPr>
         <p:spPr>
           <a:xfrm>
-            <a:off x="320040" y="2395728"/>
-            <a:ext cx="685800" cy="329184"/>
+            <a:off x="6172200" y="2302089"/>
+            <a:ext cx="685800" cy="328426"/>
           </a:xfrm>
           <a:prstGeom prst="rect">
             <a:avLst/>
@@ -5601,8 +5506,8 @@
         </p:nvSpPr>
         <p:spPr>
           <a:xfrm>
-            <a:off x="320040" y="2395728"/>
-            <a:ext cx="685800" cy="329184"/>
+            <a:off x="6172200" y="2302089"/>
+            <a:ext cx="685800" cy="328426"/>
           </a:xfrm>
           <a:prstGeom prst="rect">
             <a:avLst/>
@@ -5640,7 +5545,7 @@
         </p:nvSpPr>
         <p:spPr>
           <a:xfrm>
-            <a:off x="1005840" y="2395728"/>
+            <a:off x="6858000" y="2301331"/>
             <a:ext cx="822960" cy="329184"/>
           </a:xfrm>
           <a:prstGeom prst="rect">
@@ -5665,7 +5570,7 @@
         </p:nvSpPr>
         <p:spPr>
           <a:xfrm>
-            <a:off x="1005840" y="2395728"/>
+            <a:off x="6858000" y="2301331"/>
             <a:ext cx="822960" cy="329184"/>
           </a:xfrm>
           <a:prstGeom prst="rect">
@@ -5704,7 +5609,7 @@
         </p:nvSpPr>
         <p:spPr>
           <a:xfrm>
-            <a:off x="1828800" y="2395728"/>
+            <a:off x="7680960" y="2301331"/>
             <a:ext cx="685800" cy="329184"/>
           </a:xfrm>
           <a:prstGeom prst="rect">
@@ -5729,7 +5634,7 @@
         </p:nvSpPr>
         <p:spPr>
           <a:xfrm>
-            <a:off x="1828800" y="2395728"/>
+            <a:off x="7680960" y="2301331"/>
             <a:ext cx="685800" cy="329184"/>
           </a:xfrm>
           <a:prstGeom prst="rect">
@@ -5762,14 +5667,14 @@
       </p:sp>
       <p:sp>
         <p:nvSpPr>
-          <p:cNvPr id="38" name="Shape 36"/>
-          <p:cNvSpPr/>
-          <p:nvPr/>
-        </p:nvSpPr>
-        <p:spPr>
-          <a:xfrm>
-            <a:off x="2514600" y="2395728"/>
-            <a:ext cx="914400" cy="329184"/>
+          <p:cNvPr id="40" name="Shape 38"/>
+          <p:cNvSpPr/>
+          <p:nvPr/>
+        </p:nvSpPr>
+        <p:spPr>
+          <a:xfrm>
+            <a:off x="8366760" y="2301331"/>
+            <a:ext cx="685800" cy="329184"/>
           </a:xfrm>
           <a:prstGeom prst="rect">
             <a:avLst/>
@@ -5787,14 +5692,14 @@
       </p:sp>
       <p:sp>
         <p:nvSpPr>
-          <p:cNvPr id="39" name="Text 37"/>
-          <p:cNvSpPr/>
-          <p:nvPr/>
-        </p:nvSpPr>
-        <p:spPr>
-          <a:xfrm>
-            <a:off x="2514600" y="2395728"/>
-            <a:ext cx="914400" cy="329184"/>
+          <p:cNvPr id="41" name="Text 39"/>
+          <p:cNvSpPr/>
+          <p:nvPr/>
+        </p:nvSpPr>
+        <p:spPr>
+          <a:xfrm>
+            <a:off x="8366760" y="2301331"/>
+            <a:ext cx="685800" cy="329184"/>
           </a:xfrm>
           <a:prstGeom prst="rect">
             <a:avLst/>
@@ -5810,6 +5715,198 @@
               <a:buNone/>
             </a:pPr>
             <a:r>
+              <a:rPr lang="en-US" sz="1100" dirty="0">
+                <a:solidFill>
+                  <a:srgbClr val="1A202C"/>
+                </a:solidFill>
+                <a:latin typeface="Calibri" pitchFamily="34" charset="0"/>
+                <a:ea typeface="Calibri" pitchFamily="34" charset="-122"/>
+                <a:cs typeface="Calibri" pitchFamily="34" charset="-120"/>
+              </a:rPr>
+              <a:t>76.9%</a:t>
+            </a:r>
+            <a:endParaRPr lang="en-US" sz="1100" dirty="0"/>
+          </a:p>
+        </p:txBody>
+      </p:sp>
+      <p:sp>
+        <p:nvSpPr>
+          <p:cNvPr id="42" name="Shape 40"/>
+          <p:cNvSpPr/>
+          <p:nvPr/>
+        </p:nvSpPr>
+        <p:spPr>
+          <a:xfrm>
+            <a:off x="6172200" y="2631273"/>
+            <a:ext cx="685800" cy="328426"/>
+          </a:xfrm>
+          <a:prstGeom prst="rect">
+            <a:avLst/>
+          </a:prstGeom>
+          <a:solidFill>
+            <a:srgbClr val="F39C12"/>
+          </a:solidFill>
+          <a:ln w="12700">
+            <a:solidFill>
+              <a:srgbClr val="F39C12"/>
+            </a:solidFill>
+            <a:prstDash val="solid"/>
+          </a:ln>
+        </p:spPr>
+      </p:sp>
+      <p:sp>
+        <p:nvSpPr>
+          <p:cNvPr id="43" name="Text 41"/>
+          <p:cNvSpPr/>
+          <p:nvPr/>
+        </p:nvSpPr>
+        <p:spPr>
+          <a:xfrm>
+            <a:off x="6172200" y="2631273"/>
+            <a:ext cx="685800" cy="328426"/>
+          </a:xfrm>
+          <a:prstGeom prst="rect">
+            <a:avLst/>
+          </a:prstGeom>
+          <a:noFill/>
+          <a:ln/>
+        </p:spPr>
+        <p:txBody>
+          <a:bodyPr wrap="square" lIns="0" tIns="0" rIns="0" bIns="0" rtlCol="0" anchor="ctr"/>
+          <a:lstStyle/>
+          <a:p>
+            <a:pPr marL="0" indent="0" algn="ctr">
+              <a:buNone/>
+            </a:pPr>
+            <a:r>
+              <a:rPr lang="en-US" sz="1000" b="1" dirty="0">
+                <a:solidFill>
+                  <a:srgbClr val="FFFFFF"/>
+                </a:solidFill>
+                <a:latin typeface="Calibri" pitchFamily="34" charset="0"/>
+                <a:ea typeface="Calibri" pitchFamily="34" charset="-122"/>
+                <a:cs typeface="Calibri" pitchFamily="34" charset="-120"/>
+              </a:rPr>
+              <a:t>Stage 2</a:t>
+            </a:r>
+            <a:endParaRPr lang="en-US" sz="1000" dirty="0"/>
+          </a:p>
+        </p:txBody>
+      </p:sp>
+      <p:sp>
+        <p:nvSpPr>
+          <p:cNvPr id="44" name="Shape 42"/>
+          <p:cNvSpPr/>
+          <p:nvPr/>
+        </p:nvSpPr>
+        <p:spPr>
+          <a:xfrm>
+            <a:off x="6858000" y="2630515"/>
+            <a:ext cx="822960" cy="329184"/>
+          </a:xfrm>
+          <a:prstGeom prst="rect">
+            <a:avLst/>
+          </a:prstGeom>
+          <a:solidFill>
+            <a:srgbClr val="FFFFFF"/>
+          </a:solidFill>
+          <a:ln w="6350">
+            <a:solidFill>
+              <a:srgbClr val="E2E8F0"/>
+            </a:solidFill>
+            <a:prstDash val="solid"/>
+          </a:ln>
+        </p:spPr>
+      </p:sp>
+      <p:sp>
+        <p:nvSpPr>
+          <p:cNvPr id="45" name="Text 43"/>
+          <p:cNvSpPr/>
+          <p:nvPr/>
+        </p:nvSpPr>
+        <p:spPr>
+          <a:xfrm>
+            <a:off x="6858000" y="2630515"/>
+            <a:ext cx="822960" cy="329184"/>
+          </a:xfrm>
+          <a:prstGeom prst="rect">
+            <a:avLst/>
+          </a:prstGeom>
+          <a:noFill/>
+          <a:ln/>
+        </p:spPr>
+        <p:txBody>
+          <a:bodyPr wrap="square" lIns="0" tIns="0" rIns="0" bIns="0" rtlCol="0" anchor="ctr"/>
+          <a:lstStyle/>
+          <a:p>
+            <a:pPr marL="0" indent="0" algn="ctr">
+              <a:buNone/>
+            </a:pPr>
+            <a:r>
+              <a:rPr lang="en-US" sz="1100" dirty="0">
+                <a:solidFill>
+                  <a:srgbClr val="1A202C"/>
+                </a:solidFill>
+                <a:latin typeface="Calibri" pitchFamily="34" charset="0"/>
+                <a:ea typeface="Calibri" pitchFamily="34" charset="-122"/>
+                <a:cs typeface="Calibri" pitchFamily="34" charset="-120"/>
+              </a:rPr>
+              <a:t>85.0%</a:t>
+            </a:r>
+            <a:endParaRPr lang="en-US" sz="1100" dirty="0"/>
+          </a:p>
+        </p:txBody>
+      </p:sp>
+      <p:sp>
+        <p:nvSpPr>
+          <p:cNvPr id="46" name="Shape 44"/>
+          <p:cNvSpPr/>
+          <p:nvPr/>
+        </p:nvSpPr>
+        <p:spPr>
+          <a:xfrm>
+            <a:off x="7680960" y="2630515"/>
+            <a:ext cx="685800" cy="329184"/>
+          </a:xfrm>
+          <a:prstGeom prst="rect">
+            <a:avLst/>
+          </a:prstGeom>
+          <a:solidFill>
+            <a:srgbClr val="FFFFFF"/>
+          </a:solidFill>
+          <a:ln w="6350">
+            <a:solidFill>
+              <a:srgbClr val="E2E8F0"/>
+            </a:solidFill>
+            <a:prstDash val="solid"/>
+          </a:ln>
+        </p:spPr>
+      </p:sp>
+      <p:sp>
+        <p:nvSpPr>
+          <p:cNvPr id="47" name="Text 45"/>
+          <p:cNvSpPr/>
+          <p:nvPr/>
+        </p:nvSpPr>
+        <p:spPr>
+          <a:xfrm>
+            <a:off x="7680960" y="2630515"/>
+            <a:ext cx="685800" cy="329184"/>
+          </a:xfrm>
+          <a:prstGeom prst="rect">
+            <a:avLst/>
+          </a:prstGeom>
+          <a:noFill/>
+          <a:ln/>
+        </p:spPr>
+        <p:txBody>
+          <a:bodyPr wrap="square" lIns="0" tIns="0" rIns="0" bIns="0" rtlCol="0" anchor="ctr"/>
+          <a:lstStyle/>
+          <a:p>
+            <a:pPr marL="0" indent="0" algn="ctr">
+              <a:buNone/>
+            </a:pPr>
+            <a:r>
               <a:rPr lang="en-US" sz="1100" b="1" dirty="0">
                 <a:solidFill>
                   <a:srgbClr val="27AE60"/>
@@ -5818,7 +5915,7 @@
                 <a:ea typeface="Calibri" pitchFamily="34" charset="-122"/>
                 <a:cs typeface="Calibri" pitchFamily="34" charset="-120"/>
               </a:rPr>
-              <a:t>100.0%</a:t>
+              <a:t>94.4%</a:t>
             </a:r>
             <a:endParaRPr lang="en-US" sz="1100" dirty="0"/>
           </a:p>
@@ -5826,14 +5923,142 @@
       </p:sp>
       <p:sp>
         <p:nvSpPr>
-          <p:cNvPr id="40" name="Shape 38"/>
-          <p:cNvSpPr/>
-          <p:nvPr/>
-        </p:nvSpPr>
-        <p:spPr>
-          <a:xfrm>
-            <a:off x="3429000" y="2395728"/>
+          <p:cNvPr id="50" name="Shape 48"/>
+          <p:cNvSpPr/>
+          <p:nvPr/>
+        </p:nvSpPr>
+        <p:spPr>
+          <a:xfrm>
+            <a:off x="8366760" y="2630515"/>
             <a:ext cx="685800" cy="329184"/>
+          </a:xfrm>
+          <a:prstGeom prst="rect">
+            <a:avLst/>
+          </a:prstGeom>
+          <a:solidFill>
+            <a:srgbClr val="FFFFFF"/>
+          </a:solidFill>
+          <a:ln w="6350">
+            <a:solidFill>
+              <a:srgbClr val="E2E8F0"/>
+            </a:solidFill>
+            <a:prstDash val="solid"/>
+          </a:ln>
+        </p:spPr>
+      </p:sp>
+      <p:sp>
+        <p:nvSpPr>
+          <p:cNvPr id="51" name="Text 49"/>
+          <p:cNvSpPr/>
+          <p:nvPr/>
+        </p:nvSpPr>
+        <p:spPr>
+          <a:xfrm>
+            <a:off x="8366760" y="2630515"/>
+            <a:ext cx="685800" cy="329184"/>
+          </a:xfrm>
+          <a:prstGeom prst="rect">
+            <a:avLst/>
+          </a:prstGeom>
+          <a:noFill/>
+          <a:ln/>
+        </p:spPr>
+        <p:txBody>
+          <a:bodyPr wrap="square" lIns="0" tIns="0" rIns="0" bIns="0" rtlCol="0" anchor="ctr"/>
+          <a:lstStyle/>
+          <a:p>
+            <a:pPr marL="0" indent="0" algn="ctr">
+              <a:buNone/>
+            </a:pPr>
+            <a:r>
+              <a:rPr lang="en-US" sz="1100" dirty="0">
+                <a:solidFill>
+                  <a:srgbClr val="1A202C"/>
+                </a:solidFill>
+                <a:latin typeface="Calibri" pitchFamily="34" charset="0"/>
+                <a:ea typeface="Calibri" pitchFamily="34" charset="-122"/>
+                <a:cs typeface="Calibri" pitchFamily="34" charset="-120"/>
+              </a:rPr>
+              <a:t>89.5%</a:t>
+            </a:r>
+            <a:endParaRPr lang="en-US" sz="1100" dirty="0"/>
+          </a:p>
+        </p:txBody>
+      </p:sp>
+      <p:sp>
+        <p:nvSpPr>
+          <p:cNvPr id="52" name="Shape 50"/>
+          <p:cNvSpPr/>
+          <p:nvPr/>
+        </p:nvSpPr>
+        <p:spPr>
+          <a:xfrm>
+            <a:off x="6172200" y="2960457"/>
+            <a:ext cx="685800" cy="328426"/>
+          </a:xfrm>
+          <a:prstGeom prst="rect">
+            <a:avLst/>
+          </a:prstGeom>
+          <a:solidFill>
+            <a:srgbClr val="E67E22"/>
+          </a:solidFill>
+          <a:ln w="12700">
+            <a:solidFill>
+              <a:srgbClr val="E67E22"/>
+            </a:solidFill>
+            <a:prstDash val="solid"/>
+          </a:ln>
+        </p:spPr>
+      </p:sp>
+      <p:sp>
+        <p:nvSpPr>
+          <p:cNvPr id="53" name="Text 51"/>
+          <p:cNvSpPr/>
+          <p:nvPr/>
+        </p:nvSpPr>
+        <p:spPr>
+          <a:xfrm>
+            <a:off x="6172200" y="2960457"/>
+            <a:ext cx="685800" cy="328426"/>
+          </a:xfrm>
+          <a:prstGeom prst="rect">
+            <a:avLst/>
+          </a:prstGeom>
+          <a:noFill/>
+          <a:ln/>
+        </p:spPr>
+        <p:txBody>
+          <a:bodyPr wrap="square" lIns="0" tIns="0" rIns="0" bIns="0" rtlCol="0" anchor="ctr"/>
+          <a:lstStyle/>
+          <a:p>
+            <a:pPr marL="0" indent="0" algn="ctr">
+              <a:buNone/>
+            </a:pPr>
+            <a:r>
+              <a:rPr lang="en-US" sz="1000" b="1" dirty="0">
+                <a:solidFill>
+                  <a:srgbClr val="FFFFFF"/>
+                </a:solidFill>
+                <a:latin typeface="Calibri" pitchFamily="34" charset="0"/>
+                <a:ea typeface="Calibri" pitchFamily="34" charset="-122"/>
+                <a:cs typeface="Calibri" pitchFamily="34" charset="-120"/>
+              </a:rPr>
+              <a:t>Stage 3</a:t>
+            </a:r>
+            <a:endParaRPr lang="en-US" sz="1000" dirty="0"/>
+          </a:p>
+        </p:txBody>
+      </p:sp>
+      <p:sp>
+        <p:nvSpPr>
+          <p:cNvPr id="54" name="Shape 52"/>
+          <p:cNvSpPr/>
+          <p:nvPr/>
+        </p:nvSpPr>
+        <p:spPr>
+          <a:xfrm>
+            <a:off x="6858000" y="2959699"/>
+            <a:ext cx="822960" cy="329184"/>
           </a:xfrm>
           <a:prstGeom prst="rect">
             <a:avLst/>
@@ -5851,18 +6076,82 @@
       </p:sp>
       <p:sp>
         <p:nvSpPr>
-          <p:cNvPr id="41" name="Text 39"/>
-          <p:cNvSpPr/>
-          <p:nvPr/>
-        </p:nvSpPr>
-        <p:spPr>
-          <a:xfrm>
-            <a:off x="3429000" y="2395728"/>
+          <p:cNvPr id="55" name="Text 53"/>
+          <p:cNvSpPr/>
+          <p:nvPr/>
+        </p:nvSpPr>
+        <p:spPr>
+          <a:xfrm>
+            <a:off x="6858000" y="2959699"/>
+            <a:ext cx="822960" cy="329184"/>
+          </a:xfrm>
+          <a:prstGeom prst="rect">
+            <a:avLst/>
+          </a:prstGeom>
+          <a:noFill/>
+          <a:ln/>
+        </p:spPr>
+        <p:txBody>
+          <a:bodyPr wrap="square" lIns="0" tIns="0" rIns="0" bIns="0" rtlCol="0" anchor="ctr"/>
+          <a:lstStyle/>
+          <a:p>
+            <a:pPr marL="0" indent="0" algn="ctr">
+              <a:buNone/>
+            </a:pPr>
+            <a:r>
+              <a:rPr lang="en-US" sz="1100" dirty="0">
+                <a:solidFill>
+                  <a:srgbClr val="1A202C"/>
+                </a:solidFill>
+                <a:latin typeface="Calibri" pitchFamily="34" charset="0"/>
+                <a:ea typeface="Calibri" pitchFamily="34" charset="-122"/>
+                <a:cs typeface="Calibri" pitchFamily="34" charset="-120"/>
+              </a:rPr>
+              <a:t>80.0%</a:t>
+            </a:r>
+            <a:endParaRPr lang="en-US" sz="1100" dirty="0"/>
+          </a:p>
+        </p:txBody>
+      </p:sp>
+      <p:sp>
+        <p:nvSpPr>
+          <p:cNvPr id="56" name="Shape 54"/>
+          <p:cNvSpPr/>
+          <p:nvPr/>
+        </p:nvSpPr>
+        <p:spPr>
+          <a:xfrm>
+            <a:off x="7680960" y="2959699"/>
             <a:ext cx="685800" cy="329184"/>
           </a:xfrm>
           <a:prstGeom prst="rect">
             <a:avLst/>
           </a:prstGeom>
+          <a:solidFill>
+            <a:srgbClr val="EDF2F7"/>
+          </a:solidFill>
+          <a:ln w="6350">
+            <a:solidFill>
+              <a:srgbClr val="E2E8F0"/>
+            </a:solidFill>
+            <a:prstDash val="solid"/>
+          </a:ln>
+        </p:spPr>
+      </p:sp>
+      <p:sp>
+        <p:nvSpPr>
+          <p:cNvPr id="57" name="Text 55"/>
+          <p:cNvSpPr/>
+          <p:nvPr/>
+        </p:nvSpPr>
+        <p:spPr>
+          <a:xfrm>
+            <a:off x="7680960" y="2959699"/>
+            <a:ext cx="685800" cy="329184"/>
+          </a:xfrm>
+          <a:prstGeom prst="rect">
+            <a:avLst/>
+          </a:prstGeom>
           <a:noFill/>
           <a:ln/>
         </p:spPr>
@@ -5882,7 +6171,7 @@
                 <a:ea typeface="Calibri" pitchFamily="34" charset="-122"/>
                 <a:cs typeface="Calibri" pitchFamily="34" charset="-120"/>
               </a:rPr>
-              <a:t>76.9%</a:t>
+              <a:t>88.9%</a:t>
             </a:r>
             <a:endParaRPr lang="en-US" sz="1100" dirty="0"/>
           </a:p>
@@ -5890,24 +6179,88 @@
       </p:sp>
       <p:sp>
         <p:nvSpPr>
-          <p:cNvPr id="42" name="Shape 40"/>
-          <p:cNvSpPr/>
-          <p:nvPr/>
-        </p:nvSpPr>
-        <p:spPr>
-          <a:xfrm>
-            <a:off x="320040" y="2724912"/>
+          <p:cNvPr id="60" name="Shape 58"/>
+          <p:cNvSpPr/>
+          <p:nvPr/>
+        </p:nvSpPr>
+        <p:spPr>
+          <a:xfrm>
+            <a:off x="8366760" y="2959699"/>
             <a:ext cx="685800" cy="329184"/>
           </a:xfrm>
           <a:prstGeom prst="rect">
             <a:avLst/>
           </a:prstGeom>
           <a:solidFill>
-            <a:srgbClr val="F39C12"/>
+            <a:srgbClr val="EDF2F7"/>
+          </a:solidFill>
+          <a:ln w="6350">
+            <a:solidFill>
+              <a:srgbClr val="E2E8F0"/>
+            </a:solidFill>
+            <a:prstDash val="solid"/>
+          </a:ln>
+        </p:spPr>
+      </p:sp>
+      <p:sp>
+        <p:nvSpPr>
+          <p:cNvPr id="61" name="Text 59"/>
+          <p:cNvSpPr/>
+          <p:nvPr/>
+        </p:nvSpPr>
+        <p:spPr>
+          <a:xfrm>
+            <a:off x="8366760" y="2959699"/>
+            <a:ext cx="685800" cy="329184"/>
+          </a:xfrm>
+          <a:prstGeom prst="rect">
+            <a:avLst/>
+          </a:prstGeom>
+          <a:noFill/>
+          <a:ln/>
+        </p:spPr>
+        <p:txBody>
+          <a:bodyPr wrap="square" lIns="0" tIns="0" rIns="0" bIns="0" rtlCol="0" anchor="ctr"/>
+          <a:lstStyle/>
+          <a:p>
+            <a:pPr marL="0" indent="0" algn="ctr">
+              <a:buNone/>
+            </a:pPr>
+            <a:r>
+              <a:rPr lang="en-US" sz="1100" dirty="0">
+                <a:solidFill>
+                  <a:srgbClr val="1A202C"/>
+                </a:solidFill>
+                <a:latin typeface="Calibri" pitchFamily="34" charset="0"/>
+                <a:ea typeface="Calibri" pitchFamily="34" charset="-122"/>
+                <a:cs typeface="Calibri" pitchFamily="34" charset="-120"/>
+              </a:rPr>
+              <a:t>84.2%</a:t>
+            </a:r>
+            <a:endParaRPr lang="en-US" sz="1100" dirty="0"/>
+          </a:p>
+        </p:txBody>
+      </p:sp>
+      <p:sp>
+        <p:nvSpPr>
+          <p:cNvPr id="62" name="Shape 60"/>
+          <p:cNvSpPr/>
+          <p:nvPr/>
+        </p:nvSpPr>
+        <p:spPr>
+          <a:xfrm>
+            <a:off x="6172200" y="3289641"/>
+            <a:ext cx="685800" cy="328426"/>
+          </a:xfrm>
+          <a:prstGeom prst="rect">
+            <a:avLst/>
+          </a:prstGeom>
+          <a:solidFill>
+            <a:srgbClr val="E74C3C"/>
           </a:solidFill>
           <a:ln w="12700">
             <a:solidFill>
-              <a:srgbClr val="F39C12"/>
+              <a:srgbClr val="E74C3C"/>
             </a:solidFill>
             <a:prstDash val="solid"/>
           </a:ln>
@@ -5915,14 +6268,14 @@
       </p:sp>
       <p:sp>
         <p:nvSpPr>
-          <p:cNvPr id="43" name="Text 41"/>
-          <p:cNvSpPr/>
-          <p:nvPr/>
-        </p:nvSpPr>
-        <p:spPr>
-          <a:xfrm>
-            <a:off x="320040" y="2724912"/>
-            <a:ext cx="685800" cy="329184"/>
+          <p:cNvPr id="63" name="Text 61"/>
+          <p:cNvSpPr/>
+          <p:nvPr/>
+        </p:nvSpPr>
+        <p:spPr>
+          <a:xfrm>
+            <a:off x="6172200" y="3289641"/>
+            <a:ext cx="685800" cy="328426"/>
           </a:xfrm>
           <a:prstGeom prst="rect">
             <a:avLst/>
@@ -5946,7 +6299,7 @@
                 <a:ea typeface="Calibri" pitchFamily="34" charset="-122"/>
                 <a:cs typeface="Calibri" pitchFamily="34" charset="-120"/>
               </a:rPr>
-              <a:t>Stage 2</a:t>
+              <a:t>Stage 4</a:t>
             </a:r>
             <a:endParaRPr lang="en-US" sz="1000" dirty="0"/>
           </a:p>
@@ -5954,13 +6307,13 @@
       </p:sp>
       <p:sp>
         <p:nvSpPr>
-          <p:cNvPr id="44" name="Shape 42"/>
-          <p:cNvSpPr/>
-          <p:nvPr/>
-        </p:nvSpPr>
-        <p:spPr>
-          <a:xfrm>
-            <a:off x="1005840" y="2724912"/>
+          <p:cNvPr id="64" name="Shape 62"/>
+          <p:cNvSpPr/>
+          <p:nvPr/>
+        </p:nvSpPr>
+        <p:spPr>
+          <a:xfrm>
+            <a:off x="6858000" y="3288883"/>
             <a:ext cx="822960" cy="329184"/>
           </a:xfrm>
           <a:prstGeom prst="rect">
@@ -5979,13 +6332,13 @@
       </p:sp>
       <p:sp>
         <p:nvSpPr>
-          <p:cNvPr id="45" name="Text 43"/>
-          <p:cNvSpPr/>
-          <p:nvPr/>
-        </p:nvSpPr>
-        <p:spPr>
-          <a:xfrm>
-            <a:off x="1005840" y="2724912"/>
+          <p:cNvPr id="65" name="Text 63"/>
+          <p:cNvSpPr/>
+          <p:nvPr/>
+        </p:nvSpPr>
+        <p:spPr>
+          <a:xfrm>
+            <a:off x="6858000" y="3288883"/>
             <a:ext cx="822960" cy="329184"/>
           </a:xfrm>
           <a:prstGeom prst="rect">
@@ -6002,15 +6355,15 @@
               <a:buNone/>
             </a:pPr>
             <a:r>
-              <a:rPr lang="en-US" sz="1100" dirty="0">
-                <a:solidFill>
-                  <a:srgbClr val="1A202C"/>
-                </a:solidFill>
-                <a:latin typeface="Calibri" pitchFamily="34" charset="0"/>
-                <a:ea typeface="Calibri" pitchFamily="34" charset="-122"/>
-                <a:cs typeface="Calibri" pitchFamily="34" charset="-120"/>
-              </a:rPr>
-              <a:t>85.0%</a:t>
+              <a:rPr lang="en-US" sz="1100" b="1" dirty="0">
+                <a:solidFill>
+                  <a:srgbClr val="27AE60"/>
+                </a:solidFill>
+                <a:latin typeface="Calibri" pitchFamily="34" charset="0"/>
+                <a:ea typeface="Calibri" pitchFamily="34" charset="-122"/>
+                <a:cs typeface="Calibri" pitchFamily="34" charset="-120"/>
+              </a:rPr>
+              <a:t>100.0%</a:t>
             </a:r>
             <a:endParaRPr lang="en-US" sz="1100" dirty="0"/>
           </a:p>
@@ -6018,13 +6371,13 @@
       </p:sp>
       <p:sp>
         <p:nvSpPr>
-          <p:cNvPr id="46" name="Shape 44"/>
-          <p:cNvSpPr/>
-          <p:nvPr/>
-        </p:nvSpPr>
-        <p:spPr>
-          <a:xfrm>
-            <a:off x="1828800" y="2724912"/>
+          <p:cNvPr id="66" name="Shape 64"/>
+          <p:cNvSpPr/>
+          <p:nvPr/>
+        </p:nvSpPr>
+        <p:spPr>
+          <a:xfrm>
+            <a:off x="7680960" y="3288883"/>
             <a:ext cx="685800" cy="329184"/>
           </a:xfrm>
           <a:prstGeom prst="rect">
@@ -6043,13 +6396,13 @@
       </p:sp>
       <p:sp>
         <p:nvSpPr>
-          <p:cNvPr id="47" name="Text 45"/>
-          <p:cNvSpPr/>
-          <p:nvPr/>
-        </p:nvSpPr>
-        <p:spPr>
-          <a:xfrm>
-            <a:off x="1828800" y="2724912"/>
+          <p:cNvPr id="67" name="Text 65"/>
+          <p:cNvSpPr/>
+          <p:nvPr/>
+        </p:nvSpPr>
+        <p:spPr>
+          <a:xfrm>
+            <a:off x="7680960" y="3288883"/>
             <a:ext cx="685800" cy="329184"/>
           </a:xfrm>
           <a:prstGeom prst="rect">
@@ -6074,7 +6427,7 @@
                 <a:ea typeface="Calibri" pitchFamily="34" charset="-122"/>
                 <a:cs typeface="Calibri" pitchFamily="34" charset="-120"/>
               </a:rPr>
-              <a:t>94.4%</a:t>
+              <a:t>100.0%</a:t>
             </a:r>
             <a:endParaRPr lang="en-US" sz="1100" dirty="0"/>
           </a:p>
@@ -6082,14 +6435,14 @@
       </p:sp>
       <p:sp>
         <p:nvSpPr>
-          <p:cNvPr id="48" name="Shape 46"/>
-          <p:cNvSpPr/>
-          <p:nvPr/>
-        </p:nvSpPr>
-        <p:spPr>
-          <a:xfrm>
-            <a:off x="2514600" y="2724912"/>
-            <a:ext cx="914400" cy="329184"/>
+          <p:cNvPr id="70" name="Shape 68"/>
+          <p:cNvSpPr/>
+          <p:nvPr/>
+        </p:nvSpPr>
+        <p:spPr>
+          <a:xfrm>
+            <a:off x="8366760" y="3288883"/>
+            <a:ext cx="685800" cy="329184"/>
           </a:xfrm>
           <a:prstGeom prst="rect">
             <a:avLst/>
@@ -6107,14 +6460,14 @@
       </p:sp>
       <p:sp>
         <p:nvSpPr>
-          <p:cNvPr id="49" name="Text 47"/>
-          <p:cNvSpPr/>
-          <p:nvPr/>
-        </p:nvSpPr>
-        <p:spPr>
-          <a:xfrm>
-            <a:off x="2514600" y="2724912"/>
-            <a:ext cx="914400" cy="329184"/>
+          <p:cNvPr id="71" name="Text 69"/>
+          <p:cNvSpPr/>
+          <p:nvPr/>
+        </p:nvSpPr>
+        <p:spPr>
+          <a:xfrm>
+            <a:off x="8366760" y="3288883"/>
+            <a:ext cx="685800" cy="329184"/>
           </a:xfrm>
           <a:prstGeom prst="rect">
             <a:avLst/>
@@ -6130,15 +6483,15 @@
               <a:buNone/>
             </a:pPr>
             <a:r>
-              <a:rPr lang="en-US" sz="1100" dirty="0">
-                <a:solidFill>
-                  <a:srgbClr val="1A202C"/>
-                </a:solidFill>
-                <a:latin typeface="Calibri" pitchFamily="34" charset="0"/>
-                <a:ea typeface="Calibri" pitchFamily="34" charset="-122"/>
-                <a:cs typeface="Calibri" pitchFamily="34" charset="-120"/>
-              </a:rPr>
-              <a:t>89.3%</a:t>
+              <a:rPr lang="en-US" sz="1100" b="1" dirty="0">
+                <a:solidFill>
+                  <a:srgbClr val="27AE60"/>
+                </a:solidFill>
+                <a:latin typeface="Calibri" pitchFamily="34" charset="0"/>
+                <a:ea typeface="Calibri" pitchFamily="34" charset="-122"/>
+                <a:cs typeface="Calibri" pitchFamily="34" charset="-120"/>
+              </a:rPr>
+              <a:t>100.0%</a:t>
             </a:r>
             <a:endParaRPr lang="en-US" sz="1100" dirty="0"/>
           </a:p>
@@ -6146,718 +6499,14 @@
       </p:sp>
       <p:sp>
         <p:nvSpPr>
-          <p:cNvPr id="50" name="Shape 48"/>
-          <p:cNvSpPr/>
-          <p:nvPr/>
-        </p:nvSpPr>
-        <p:spPr>
-          <a:xfrm>
-            <a:off x="3429000" y="2724912"/>
-            <a:ext cx="685800" cy="329184"/>
-          </a:xfrm>
-          <a:prstGeom prst="rect">
-            <a:avLst/>
-          </a:prstGeom>
-          <a:solidFill>
-            <a:srgbClr val="FFFFFF"/>
-          </a:solidFill>
-          <a:ln w="6350">
-            <a:solidFill>
-              <a:srgbClr val="E2E8F0"/>
-            </a:solidFill>
-            <a:prstDash val="solid"/>
-          </a:ln>
-        </p:spPr>
-      </p:sp>
-      <p:sp>
-        <p:nvSpPr>
-          <p:cNvPr id="51" name="Text 49"/>
-          <p:cNvSpPr/>
-          <p:nvPr/>
-        </p:nvSpPr>
-        <p:spPr>
-          <a:xfrm>
-            <a:off x="3429000" y="2724912"/>
-            <a:ext cx="685800" cy="329184"/>
-          </a:xfrm>
-          <a:prstGeom prst="rect">
-            <a:avLst/>
-          </a:prstGeom>
-          <a:noFill/>
-          <a:ln/>
-        </p:spPr>
-        <p:txBody>
-          <a:bodyPr wrap="square" lIns="0" tIns="0" rIns="0" bIns="0" rtlCol="0" anchor="ctr"/>
-          <a:lstStyle/>
-          <a:p>
-            <a:pPr marL="0" indent="0" algn="ctr">
-              <a:buNone/>
-            </a:pPr>
-            <a:r>
-              <a:rPr lang="en-US" sz="1100" dirty="0">
-                <a:solidFill>
-                  <a:srgbClr val="1A202C"/>
-                </a:solidFill>
-                <a:latin typeface="Calibri" pitchFamily="34" charset="0"/>
-                <a:ea typeface="Calibri" pitchFamily="34" charset="-122"/>
-                <a:cs typeface="Calibri" pitchFamily="34" charset="-120"/>
-              </a:rPr>
-              <a:t>89.5%</a:t>
-            </a:r>
-            <a:endParaRPr lang="en-US" sz="1100" dirty="0"/>
-          </a:p>
-        </p:txBody>
-      </p:sp>
-      <p:sp>
-        <p:nvSpPr>
-          <p:cNvPr id="52" name="Shape 50"/>
-          <p:cNvSpPr/>
-          <p:nvPr/>
-        </p:nvSpPr>
-        <p:spPr>
-          <a:xfrm>
-            <a:off x="320040" y="3054096"/>
-            <a:ext cx="685800" cy="329184"/>
-          </a:xfrm>
-          <a:prstGeom prst="rect">
-            <a:avLst/>
-          </a:prstGeom>
-          <a:solidFill>
-            <a:srgbClr val="E67E22"/>
-          </a:solidFill>
-          <a:ln w="12700">
-            <a:solidFill>
-              <a:srgbClr val="E67E22"/>
-            </a:solidFill>
-            <a:prstDash val="solid"/>
-          </a:ln>
-        </p:spPr>
-      </p:sp>
-      <p:sp>
-        <p:nvSpPr>
-          <p:cNvPr id="53" name="Text 51"/>
-          <p:cNvSpPr/>
-          <p:nvPr/>
-        </p:nvSpPr>
-        <p:spPr>
-          <a:xfrm>
-            <a:off x="320040" y="3054096"/>
-            <a:ext cx="685800" cy="329184"/>
-          </a:xfrm>
-          <a:prstGeom prst="rect">
-            <a:avLst/>
-          </a:prstGeom>
-          <a:noFill/>
-          <a:ln/>
-        </p:spPr>
-        <p:txBody>
-          <a:bodyPr wrap="square" lIns="0" tIns="0" rIns="0" bIns="0" rtlCol="0" anchor="ctr"/>
-          <a:lstStyle/>
-          <a:p>
-            <a:pPr marL="0" indent="0" algn="ctr">
-              <a:buNone/>
-            </a:pPr>
-            <a:r>
-              <a:rPr lang="en-US" sz="1000" b="1" dirty="0">
-                <a:solidFill>
-                  <a:srgbClr val="FFFFFF"/>
-                </a:solidFill>
-                <a:latin typeface="Calibri" pitchFamily="34" charset="0"/>
-                <a:ea typeface="Calibri" pitchFamily="34" charset="-122"/>
-                <a:cs typeface="Calibri" pitchFamily="34" charset="-120"/>
-              </a:rPr>
-              <a:t>Stage 3</a:t>
-            </a:r>
-            <a:endParaRPr lang="en-US" sz="1000" dirty="0"/>
-          </a:p>
-        </p:txBody>
-      </p:sp>
-      <p:sp>
-        <p:nvSpPr>
-          <p:cNvPr id="54" name="Shape 52"/>
-          <p:cNvSpPr/>
-          <p:nvPr/>
-        </p:nvSpPr>
-        <p:spPr>
-          <a:xfrm>
-            <a:off x="1005840" y="3054096"/>
-            <a:ext cx="822960" cy="329184"/>
-          </a:xfrm>
-          <a:prstGeom prst="rect">
-            <a:avLst/>
-          </a:prstGeom>
-          <a:solidFill>
-            <a:srgbClr val="EDF2F7"/>
-          </a:solidFill>
-          <a:ln w="6350">
-            <a:solidFill>
-              <a:srgbClr val="E2E8F0"/>
-            </a:solidFill>
-            <a:prstDash val="solid"/>
-          </a:ln>
-        </p:spPr>
-      </p:sp>
-      <p:sp>
-        <p:nvSpPr>
-          <p:cNvPr id="55" name="Text 53"/>
-          <p:cNvSpPr/>
-          <p:nvPr/>
-        </p:nvSpPr>
-        <p:spPr>
-          <a:xfrm>
-            <a:off x="1005840" y="3054096"/>
-            <a:ext cx="822960" cy="329184"/>
-          </a:xfrm>
-          <a:prstGeom prst="rect">
-            <a:avLst/>
-          </a:prstGeom>
-          <a:noFill/>
-          <a:ln/>
-        </p:spPr>
-        <p:txBody>
-          <a:bodyPr wrap="square" lIns="0" tIns="0" rIns="0" bIns="0" rtlCol="0" anchor="ctr"/>
-          <a:lstStyle/>
-          <a:p>
-            <a:pPr marL="0" indent="0" algn="ctr">
-              <a:buNone/>
-            </a:pPr>
-            <a:r>
-              <a:rPr lang="en-US" sz="1100" dirty="0">
-                <a:solidFill>
-                  <a:srgbClr val="1A202C"/>
-                </a:solidFill>
-                <a:latin typeface="Calibri" pitchFamily="34" charset="0"/>
-                <a:ea typeface="Calibri" pitchFamily="34" charset="-122"/>
-                <a:cs typeface="Calibri" pitchFamily="34" charset="-120"/>
-              </a:rPr>
-              <a:t>80.0%</a:t>
-            </a:r>
-            <a:endParaRPr lang="en-US" sz="1100" dirty="0"/>
-          </a:p>
-        </p:txBody>
-      </p:sp>
-      <p:sp>
-        <p:nvSpPr>
-          <p:cNvPr id="56" name="Shape 54"/>
-          <p:cNvSpPr/>
-          <p:nvPr/>
-        </p:nvSpPr>
-        <p:spPr>
-          <a:xfrm>
-            <a:off x="1828800" y="3054096"/>
-            <a:ext cx="685800" cy="329184"/>
-          </a:xfrm>
-          <a:prstGeom prst="rect">
-            <a:avLst/>
-          </a:prstGeom>
-          <a:solidFill>
-            <a:srgbClr val="EDF2F7"/>
-          </a:solidFill>
-          <a:ln w="6350">
-            <a:solidFill>
-              <a:srgbClr val="E2E8F0"/>
-            </a:solidFill>
-            <a:prstDash val="solid"/>
-          </a:ln>
-        </p:spPr>
-      </p:sp>
-      <p:sp>
-        <p:nvSpPr>
-          <p:cNvPr id="57" name="Text 55"/>
-          <p:cNvSpPr/>
-          <p:nvPr/>
-        </p:nvSpPr>
-        <p:spPr>
-          <a:xfrm>
-            <a:off x="1828800" y="3054096"/>
-            <a:ext cx="685800" cy="329184"/>
-          </a:xfrm>
-          <a:prstGeom prst="rect">
-            <a:avLst/>
-          </a:prstGeom>
-          <a:noFill/>
-          <a:ln/>
-        </p:spPr>
-        <p:txBody>
-          <a:bodyPr wrap="square" lIns="0" tIns="0" rIns="0" bIns="0" rtlCol="0" anchor="ctr"/>
-          <a:lstStyle/>
-          <a:p>
-            <a:pPr marL="0" indent="0" algn="ctr">
-              <a:buNone/>
-            </a:pPr>
-            <a:r>
-              <a:rPr lang="en-US" sz="1100" dirty="0">
-                <a:solidFill>
-                  <a:srgbClr val="1A202C"/>
-                </a:solidFill>
-                <a:latin typeface="Calibri" pitchFamily="34" charset="0"/>
-                <a:ea typeface="Calibri" pitchFamily="34" charset="-122"/>
-                <a:cs typeface="Calibri" pitchFamily="34" charset="-120"/>
-              </a:rPr>
-              <a:t>88.9%</a:t>
-            </a:r>
-            <a:endParaRPr lang="en-US" sz="1100" dirty="0"/>
-          </a:p>
-        </p:txBody>
-      </p:sp>
-      <p:sp>
-        <p:nvSpPr>
-          <p:cNvPr id="58" name="Shape 56"/>
-          <p:cNvSpPr/>
-          <p:nvPr/>
-        </p:nvSpPr>
-        <p:spPr>
-          <a:xfrm>
-            <a:off x="2514600" y="3054096"/>
-            <a:ext cx="914400" cy="329184"/>
-          </a:xfrm>
-          <a:prstGeom prst="rect">
-            <a:avLst/>
-          </a:prstGeom>
-          <a:solidFill>
-            <a:srgbClr val="EDF2F7"/>
-          </a:solidFill>
-          <a:ln w="6350">
-            <a:solidFill>
-              <a:srgbClr val="E2E8F0"/>
-            </a:solidFill>
-            <a:prstDash val="solid"/>
-          </a:ln>
-        </p:spPr>
-      </p:sp>
-      <p:sp>
-        <p:nvSpPr>
-          <p:cNvPr id="59" name="Text 57"/>
-          <p:cNvSpPr/>
-          <p:nvPr/>
-        </p:nvSpPr>
-        <p:spPr>
-          <a:xfrm>
-            <a:off x="2514600" y="3054096"/>
-            <a:ext cx="914400" cy="329184"/>
-          </a:xfrm>
-          <a:prstGeom prst="rect">
-            <a:avLst/>
-          </a:prstGeom>
-          <a:noFill/>
-          <a:ln/>
-        </p:spPr>
-        <p:txBody>
-          <a:bodyPr wrap="square" lIns="0" tIns="0" rIns="0" bIns="0" rtlCol="0" anchor="ctr"/>
-          <a:lstStyle/>
-          <a:p>
-            <a:pPr marL="0" indent="0" algn="ctr">
-              <a:buNone/>
-            </a:pPr>
-            <a:r>
-              <a:rPr lang="en-US" sz="1100" b="1" dirty="0">
-                <a:solidFill>
-                  <a:srgbClr val="27AE60"/>
-                </a:solidFill>
-                <a:latin typeface="Calibri" pitchFamily="34" charset="0"/>
-                <a:ea typeface="Calibri" pitchFamily="34" charset="-122"/>
-                <a:cs typeface="Calibri" pitchFamily="34" charset="-120"/>
-              </a:rPr>
-              <a:t>94.6%</a:t>
-            </a:r>
-            <a:endParaRPr lang="en-US" sz="1100" dirty="0"/>
-          </a:p>
-        </p:txBody>
-      </p:sp>
-      <p:sp>
-        <p:nvSpPr>
-          <p:cNvPr id="60" name="Shape 58"/>
-          <p:cNvSpPr/>
-          <p:nvPr/>
-        </p:nvSpPr>
-        <p:spPr>
-          <a:xfrm>
-            <a:off x="3429000" y="3054096"/>
-            <a:ext cx="685800" cy="329184"/>
-          </a:xfrm>
-          <a:prstGeom prst="rect">
-            <a:avLst/>
-          </a:prstGeom>
-          <a:solidFill>
-            <a:srgbClr val="EDF2F7"/>
-          </a:solidFill>
-          <a:ln w="6350">
-            <a:solidFill>
-              <a:srgbClr val="E2E8F0"/>
-            </a:solidFill>
-            <a:prstDash val="solid"/>
-          </a:ln>
-        </p:spPr>
-      </p:sp>
-      <p:sp>
-        <p:nvSpPr>
-          <p:cNvPr id="61" name="Text 59"/>
-          <p:cNvSpPr/>
-          <p:nvPr/>
-        </p:nvSpPr>
-        <p:spPr>
-          <a:xfrm>
-            <a:off x="3429000" y="3054096"/>
-            <a:ext cx="685800" cy="329184"/>
-          </a:xfrm>
-          <a:prstGeom prst="rect">
-            <a:avLst/>
-          </a:prstGeom>
-          <a:noFill/>
-          <a:ln/>
-        </p:spPr>
-        <p:txBody>
-          <a:bodyPr wrap="square" lIns="0" tIns="0" rIns="0" bIns="0" rtlCol="0" anchor="ctr"/>
-          <a:lstStyle/>
-          <a:p>
-            <a:pPr marL="0" indent="0" algn="ctr">
-              <a:buNone/>
-            </a:pPr>
-            <a:r>
-              <a:rPr lang="en-US" sz="1100" dirty="0">
-                <a:solidFill>
-                  <a:srgbClr val="1A202C"/>
-                </a:solidFill>
-                <a:latin typeface="Calibri" pitchFamily="34" charset="0"/>
-                <a:ea typeface="Calibri" pitchFamily="34" charset="-122"/>
-                <a:cs typeface="Calibri" pitchFamily="34" charset="-120"/>
-              </a:rPr>
-              <a:t>84.2%</a:t>
-            </a:r>
-            <a:endParaRPr lang="en-US" sz="1100" dirty="0"/>
-          </a:p>
-        </p:txBody>
-      </p:sp>
-      <p:sp>
-        <p:nvSpPr>
-          <p:cNvPr id="62" name="Shape 60"/>
-          <p:cNvSpPr/>
-          <p:nvPr/>
-        </p:nvSpPr>
-        <p:spPr>
-          <a:xfrm>
-            <a:off x="320040" y="3383280"/>
-            <a:ext cx="685800" cy="329184"/>
-          </a:xfrm>
-          <a:prstGeom prst="rect">
-            <a:avLst/>
-          </a:prstGeom>
-          <a:solidFill>
-            <a:srgbClr val="E74C3C"/>
-          </a:solidFill>
-          <a:ln w="12700">
-            <a:solidFill>
-              <a:srgbClr val="E74C3C"/>
-            </a:solidFill>
-            <a:prstDash val="solid"/>
-          </a:ln>
-        </p:spPr>
-      </p:sp>
-      <p:sp>
-        <p:nvSpPr>
-          <p:cNvPr id="63" name="Text 61"/>
-          <p:cNvSpPr/>
-          <p:nvPr/>
-        </p:nvSpPr>
-        <p:spPr>
-          <a:xfrm>
-            <a:off x="320040" y="3383280"/>
-            <a:ext cx="685800" cy="329184"/>
-          </a:xfrm>
-          <a:prstGeom prst="rect">
-            <a:avLst/>
-          </a:prstGeom>
-          <a:noFill/>
-          <a:ln/>
-        </p:spPr>
-        <p:txBody>
-          <a:bodyPr wrap="square" lIns="0" tIns="0" rIns="0" bIns="0" rtlCol="0" anchor="ctr"/>
-          <a:lstStyle/>
-          <a:p>
-            <a:pPr marL="0" indent="0" algn="ctr">
-              <a:buNone/>
-            </a:pPr>
-            <a:r>
-              <a:rPr lang="en-US" sz="1000" b="1" dirty="0">
-                <a:solidFill>
-                  <a:srgbClr val="FFFFFF"/>
-                </a:solidFill>
-                <a:latin typeface="Calibri" pitchFamily="34" charset="0"/>
-                <a:ea typeface="Calibri" pitchFamily="34" charset="-122"/>
-                <a:cs typeface="Calibri" pitchFamily="34" charset="-120"/>
-              </a:rPr>
-              <a:t>Stage 4</a:t>
-            </a:r>
-            <a:endParaRPr lang="en-US" sz="1000" dirty="0"/>
-          </a:p>
-        </p:txBody>
-      </p:sp>
-      <p:sp>
-        <p:nvSpPr>
-          <p:cNvPr id="64" name="Shape 62"/>
-          <p:cNvSpPr/>
-          <p:nvPr/>
-        </p:nvSpPr>
-        <p:spPr>
-          <a:xfrm>
-            <a:off x="1005840" y="3383280"/>
-            <a:ext cx="822960" cy="329184"/>
-          </a:xfrm>
-          <a:prstGeom prst="rect">
-            <a:avLst/>
-          </a:prstGeom>
-          <a:solidFill>
-            <a:srgbClr val="FFFFFF"/>
-          </a:solidFill>
-          <a:ln w="6350">
-            <a:solidFill>
-              <a:srgbClr val="E2E8F0"/>
-            </a:solidFill>
-            <a:prstDash val="solid"/>
-          </a:ln>
-        </p:spPr>
-      </p:sp>
-      <p:sp>
-        <p:nvSpPr>
-          <p:cNvPr id="65" name="Text 63"/>
-          <p:cNvSpPr/>
-          <p:nvPr/>
-        </p:nvSpPr>
-        <p:spPr>
-          <a:xfrm>
-            <a:off x="1005840" y="3383280"/>
-            <a:ext cx="822960" cy="329184"/>
-          </a:xfrm>
-          <a:prstGeom prst="rect">
-            <a:avLst/>
-          </a:prstGeom>
-          <a:noFill/>
-          <a:ln/>
-        </p:spPr>
-        <p:txBody>
-          <a:bodyPr wrap="square" lIns="0" tIns="0" rIns="0" bIns="0" rtlCol="0" anchor="ctr"/>
-          <a:lstStyle/>
-          <a:p>
-            <a:pPr marL="0" indent="0" algn="ctr">
-              <a:buNone/>
-            </a:pPr>
-            <a:r>
-              <a:rPr lang="en-US" sz="1100" b="1" dirty="0">
-                <a:solidFill>
-                  <a:srgbClr val="27AE60"/>
-                </a:solidFill>
-                <a:latin typeface="Calibri" pitchFamily="34" charset="0"/>
-                <a:ea typeface="Calibri" pitchFamily="34" charset="-122"/>
-                <a:cs typeface="Calibri" pitchFamily="34" charset="-120"/>
-              </a:rPr>
-              <a:t>100.0%</a:t>
-            </a:r>
-            <a:endParaRPr lang="en-US" sz="1100" dirty="0"/>
-          </a:p>
-        </p:txBody>
-      </p:sp>
-      <p:sp>
-        <p:nvSpPr>
-          <p:cNvPr id="66" name="Shape 64"/>
-          <p:cNvSpPr/>
-          <p:nvPr/>
-        </p:nvSpPr>
-        <p:spPr>
-          <a:xfrm>
-            <a:off x="1828800" y="3383280"/>
-            <a:ext cx="685800" cy="329184"/>
-          </a:xfrm>
-          <a:prstGeom prst="rect">
-            <a:avLst/>
-          </a:prstGeom>
-          <a:solidFill>
-            <a:srgbClr val="FFFFFF"/>
-          </a:solidFill>
-          <a:ln w="6350">
-            <a:solidFill>
-              <a:srgbClr val="E2E8F0"/>
-            </a:solidFill>
-            <a:prstDash val="solid"/>
-          </a:ln>
-        </p:spPr>
-      </p:sp>
-      <p:sp>
-        <p:nvSpPr>
-          <p:cNvPr id="67" name="Text 65"/>
-          <p:cNvSpPr/>
-          <p:nvPr/>
-        </p:nvSpPr>
-        <p:spPr>
-          <a:xfrm>
-            <a:off x="1828800" y="3383280"/>
-            <a:ext cx="685800" cy="329184"/>
-          </a:xfrm>
-          <a:prstGeom prst="rect">
-            <a:avLst/>
-          </a:prstGeom>
-          <a:noFill/>
-          <a:ln/>
-        </p:spPr>
-        <p:txBody>
-          <a:bodyPr wrap="square" lIns="0" tIns="0" rIns="0" bIns="0" rtlCol="0" anchor="ctr"/>
-          <a:lstStyle/>
-          <a:p>
-            <a:pPr marL="0" indent="0" algn="ctr">
-              <a:buNone/>
-            </a:pPr>
-            <a:r>
-              <a:rPr lang="en-US" sz="1100" b="1" dirty="0">
-                <a:solidFill>
-                  <a:srgbClr val="27AE60"/>
-                </a:solidFill>
-                <a:latin typeface="Calibri" pitchFamily="34" charset="0"/>
-                <a:ea typeface="Calibri" pitchFamily="34" charset="-122"/>
-                <a:cs typeface="Calibri" pitchFamily="34" charset="-120"/>
-              </a:rPr>
-              <a:t>100.0%</a:t>
-            </a:r>
-            <a:endParaRPr lang="en-US" sz="1100" dirty="0"/>
-          </a:p>
-        </p:txBody>
-      </p:sp>
-      <p:sp>
-        <p:nvSpPr>
-          <p:cNvPr id="68" name="Shape 66"/>
-          <p:cNvSpPr/>
-          <p:nvPr/>
-        </p:nvSpPr>
-        <p:spPr>
-          <a:xfrm>
-            <a:off x="2514600" y="3383280"/>
-            <a:ext cx="914400" cy="329184"/>
-          </a:xfrm>
-          <a:prstGeom prst="rect">
-            <a:avLst/>
-          </a:prstGeom>
-          <a:solidFill>
-            <a:srgbClr val="FFFFFF"/>
-          </a:solidFill>
-          <a:ln w="6350">
-            <a:solidFill>
-              <a:srgbClr val="E2E8F0"/>
-            </a:solidFill>
-            <a:prstDash val="solid"/>
-          </a:ln>
-        </p:spPr>
-      </p:sp>
-      <p:sp>
-        <p:nvSpPr>
-          <p:cNvPr id="69" name="Text 67"/>
-          <p:cNvSpPr/>
-          <p:nvPr/>
-        </p:nvSpPr>
-        <p:spPr>
-          <a:xfrm>
-            <a:off x="2514600" y="3383280"/>
-            <a:ext cx="914400" cy="329184"/>
-          </a:xfrm>
-          <a:prstGeom prst="rect">
-            <a:avLst/>
-          </a:prstGeom>
-          <a:noFill/>
-          <a:ln/>
-        </p:spPr>
-        <p:txBody>
-          <a:bodyPr wrap="square" lIns="0" tIns="0" rIns="0" bIns="0" rtlCol="0" anchor="ctr"/>
-          <a:lstStyle/>
-          <a:p>
-            <a:pPr marL="0" indent="0" algn="ctr">
-              <a:buNone/>
-            </a:pPr>
-            <a:r>
-              <a:rPr lang="en-US" sz="1100" b="1" dirty="0">
-                <a:solidFill>
-                  <a:srgbClr val="27AE60"/>
-                </a:solidFill>
-                <a:latin typeface="Calibri" pitchFamily="34" charset="0"/>
-                <a:ea typeface="Calibri" pitchFamily="34" charset="-122"/>
-                <a:cs typeface="Calibri" pitchFamily="34" charset="-120"/>
-              </a:rPr>
-              <a:t>100.0%</a:t>
-            </a:r>
-            <a:endParaRPr lang="en-US" sz="1100" dirty="0"/>
-          </a:p>
-        </p:txBody>
-      </p:sp>
-      <p:sp>
-        <p:nvSpPr>
-          <p:cNvPr id="70" name="Shape 68"/>
-          <p:cNvSpPr/>
-          <p:nvPr/>
-        </p:nvSpPr>
-        <p:spPr>
-          <a:xfrm>
-            <a:off x="3429000" y="3383280"/>
-            <a:ext cx="685800" cy="329184"/>
-          </a:xfrm>
-          <a:prstGeom prst="rect">
-            <a:avLst/>
-          </a:prstGeom>
-          <a:solidFill>
-            <a:srgbClr val="FFFFFF"/>
-          </a:solidFill>
-          <a:ln w="6350">
-            <a:solidFill>
-              <a:srgbClr val="E2E8F0"/>
-            </a:solidFill>
-            <a:prstDash val="solid"/>
-          </a:ln>
-        </p:spPr>
-      </p:sp>
-      <p:sp>
-        <p:nvSpPr>
-          <p:cNvPr id="71" name="Text 69"/>
-          <p:cNvSpPr/>
-          <p:nvPr/>
-        </p:nvSpPr>
-        <p:spPr>
-          <a:xfrm>
-            <a:off x="3429000" y="3383280"/>
-            <a:ext cx="685800" cy="329184"/>
-          </a:xfrm>
-          <a:prstGeom prst="rect">
-            <a:avLst/>
-          </a:prstGeom>
-          <a:noFill/>
-          <a:ln/>
-        </p:spPr>
-        <p:txBody>
-          <a:bodyPr wrap="square" lIns="0" tIns="0" rIns="0" bIns="0" rtlCol="0" anchor="ctr"/>
-          <a:lstStyle/>
-          <a:p>
-            <a:pPr marL="0" indent="0" algn="ctr">
-              <a:buNone/>
-            </a:pPr>
-            <a:r>
-              <a:rPr lang="en-US" sz="1100" b="1" dirty="0">
-                <a:solidFill>
-                  <a:srgbClr val="27AE60"/>
-                </a:solidFill>
-                <a:latin typeface="Calibri" pitchFamily="34" charset="0"/>
-                <a:ea typeface="Calibri" pitchFamily="34" charset="-122"/>
-                <a:cs typeface="Calibri" pitchFamily="34" charset="-120"/>
-              </a:rPr>
-              <a:t>100.0%</a:t>
-            </a:r>
-            <a:endParaRPr lang="en-US" sz="1100" dirty="0"/>
-          </a:p>
-        </p:txBody>
-      </p:sp>
-      <p:sp>
-        <p:nvSpPr>
           <p:cNvPr id="72" name="Shape 70"/>
           <p:cNvSpPr/>
           <p:nvPr/>
         </p:nvSpPr>
         <p:spPr>
           <a:xfrm>
-            <a:off x="320040" y="3712464"/>
-            <a:ext cx="685800" cy="329184"/>
+            <a:off x="6172200" y="3618825"/>
+            <a:ext cx="685800" cy="328426"/>
           </a:xfrm>
           <a:prstGeom prst="rect">
             <a:avLst/>
@@ -6881,8 +6530,8 @@
         </p:nvSpPr>
         <p:spPr>
           <a:xfrm>
-            <a:off x="320040" y="3712464"/>
-            <a:ext cx="685800" cy="329184"/>
+            <a:off x="6172200" y="3618825"/>
+            <a:ext cx="685800" cy="328426"/>
           </a:xfrm>
           <a:prstGeom prst="rect">
             <a:avLst/>
@@ -6920,7 +6569,7 @@
         </p:nvSpPr>
         <p:spPr>
           <a:xfrm>
-            <a:off x="1005840" y="3712464"/>
+            <a:off x="6858000" y="3618067"/>
             <a:ext cx="822960" cy="329184"/>
           </a:xfrm>
           <a:prstGeom prst="rect">
@@ -6945,7 +6594,7 @@
         </p:nvSpPr>
         <p:spPr>
           <a:xfrm>
-            <a:off x="1005840" y="3712464"/>
+            <a:off x="6858000" y="3618067"/>
             <a:ext cx="822960" cy="329184"/>
           </a:xfrm>
           <a:prstGeom prst="rect">
@@ -6984,7 +6633,7 @@
         </p:nvSpPr>
         <p:spPr>
           <a:xfrm>
-            <a:off x="1828800" y="3712464"/>
+            <a:off x="7680960" y="3618067"/>
             <a:ext cx="685800" cy="329184"/>
           </a:xfrm>
           <a:prstGeom prst="rect">
@@ -7009,7 +6658,7 @@
         </p:nvSpPr>
         <p:spPr>
           <a:xfrm>
-            <a:off x="1828800" y="3712464"/>
+            <a:off x="7680960" y="3618067"/>
             <a:ext cx="685800" cy="329184"/>
           </a:xfrm>
           <a:prstGeom prst="rect">
@@ -7042,14 +6691,14 @@
       </p:sp>
       <p:sp>
         <p:nvSpPr>
-          <p:cNvPr id="78" name="Shape 76"/>
-          <p:cNvSpPr/>
-          <p:nvPr/>
-        </p:nvSpPr>
-        <p:spPr>
-          <a:xfrm>
-            <a:off x="2514600" y="3712464"/>
-            <a:ext cx="914400" cy="329184"/>
+          <p:cNvPr id="80" name="Shape 78"/>
+          <p:cNvSpPr/>
+          <p:nvPr/>
+        </p:nvSpPr>
+        <p:spPr>
+          <a:xfrm>
+            <a:off x="8366760" y="3618067"/>
+            <a:ext cx="685800" cy="329184"/>
           </a:xfrm>
           <a:prstGeom prst="rect">
             <a:avLst/>
@@ -7067,14 +6716,14 @@
       </p:sp>
       <p:sp>
         <p:nvSpPr>
-          <p:cNvPr id="79" name="Text 77"/>
-          <p:cNvSpPr/>
-          <p:nvPr/>
-        </p:nvSpPr>
-        <p:spPr>
-          <a:xfrm>
-            <a:off x="2514600" y="3712464"/>
-            <a:ext cx="914400" cy="329184"/>
+          <p:cNvPr id="81" name="Text 79"/>
+          <p:cNvSpPr/>
+          <p:nvPr/>
+        </p:nvSpPr>
+        <p:spPr>
+          <a:xfrm>
+            <a:off x="8366760" y="3618067"/>
+            <a:ext cx="685800" cy="329184"/>
           </a:xfrm>
           <a:prstGeom prst="rect">
             <a:avLst/>
@@ -7098,7 +6747,7 @@
                 <a:ea typeface="Calibri" pitchFamily="34" charset="-122"/>
                 <a:cs typeface="Calibri" pitchFamily="34" charset="-120"/>
               </a:rPr>
-              <a:t>96.0%</a:t>
+              <a:t>87.7%</a:t>
             </a:r>
             <a:endParaRPr lang="en-US" sz="1100" dirty="0"/>
           </a:p>
@@ -7106,78 +6755,14 @@
       </p:sp>
       <p:sp>
         <p:nvSpPr>
-          <p:cNvPr id="80" name="Shape 78"/>
-          <p:cNvSpPr/>
-          <p:nvPr/>
-        </p:nvSpPr>
-        <p:spPr>
-          <a:xfrm>
-            <a:off x="3429000" y="3712464"/>
-            <a:ext cx="685800" cy="329184"/>
-          </a:xfrm>
-          <a:prstGeom prst="rect">
-            <a:avLst/>
-          </a:prstGeom>
-          <a:solidFill>
-            <a:srgbClr val="EBF4FF"/>
-          </a:solidFill>
-          <a:ln w="6350">
-            <a:solidFill>
-              <a:srgbClr val="BEE3F8"/>
-            </a:solidFill>
-            <a:prstDash val="solid"/>
-          </a:ln>
-        </p:spPr>
-      </p:sp>
-      <p:sp>
-        <p:nvSpPr>
-          <p:cNvPr id="81" name="Text 79"/>
-          <p:cNvSpPr/>
-          <p:nvPr/>
-        </p:nvSpPr>
-        <p:spPr>
-          <a:xfrm>
-            <a:off x="3429000" y="3712464"/>
-            <a:ext cx="685800" cy="329184"/>
-          </a:xfrm>
-          <a:prstGeom prst="rect">
-            <a:avLst/>
-          </a:prstGeom>
-          <a:noFill/>
-          <a:ln/>
-        </p:spPr>
-        <p:txBody>
-          <a:bodyPr wrap="square" lIns="0" tIns="0" rIns="0" bIns="0" rtlCol="0" anchor="ctr"/>
-          <a:lstStyle/>
-          <a:p>
-            <a:pPr marL="0" indent="0" algn="ctr">
-              <a:buNone/>
-            </a:pPr>
-            <a:r>
-              <a:rPr lang="en-US" sz="1100" b="1" dirty="0">
-                <a:solidFill>
-                  <a:srgbClr val="065A82"/>
-                </a:solidFill>
-                <a:latin typeface="Calibri" pitchFamily="34" charset="0"/>
-                <a:ea typeface="Calibri" pitchFamily="34" charset="-122"/>
-                <a:cs typeface="Calibri" pitchFamily="34" charset="-120"/>
-              </a:rPr>
-              <a:t>87.7%</a:t>
-            </a:r>
-            <a:endParaRPr lang="en-US" sz="1100" dirty="0"/>
-          </a:p>
-        </p:txBody>
-      </p:sp>
-      <p:sp>
-        <p:nvSpPr>
           <p:cNvPr id="82" name="Shape 80"/>
           <p:cNvSpPr/>
           <p:nvPr/>
         </p:nvSpPr>
         <p:spPr>
           <a:xfrm>
-            <a:off x="320040" y="4187952"/>
-            <a:ext cx="4297680" cy="475488"/>
+            <a:off x="6172200" y="4100500"/>
+            <a:ext cx="2880360" cy="475488"/>
           </a:xfrm>
           <a:prstGeom prst="rect">
             <a:avLst/>
@@ -7201,8 +6786,8 @@
         </p:nvSpPr>
         <p:spPr>
           <a:xfrm>
-            <a:off x="411480" y="4187952"/>
-            <a:ext cx="4114800" cy="475488"/>
+            <a:off x="6263640" y="4100500"/>
+            <a:ext cx="2788920" cy="475488"/>
           </a:xfrm>
           <a:prstGeom prst="rect">
             <a:avLst/>
@@ -7240,7 +6825,7 @@
         </p:nvSpPr>
         <p:spPr>
           <a:xfrm>
-            <a:off x="4892040" y="3924271"/>
+            <a:off x="3356682" y="4307253"/>
             <a:ext cx="4023360" cy="292608"/>
           </a:xfrm>
           <a:prstGeom prst="rect">
@@ -7273,53 +6858,14 @@
       </p:sp>
       <p:sp>
         <p:nvSpPr>
-          <p:cNvPr id="86" name="Text 84"/>
-          <p:cNvSpPr/>
-          <p:nvPr/>
-        </p:nvSpPr>
-        <p:spPr>
-          <a:xfrm>
-            <a:off x="5486400" y="4462272"/>
-            <a:ext cx="2816352" cy="274320"/>
-          </a:xfrm>
-          <a:prstGeom prst="rect">
-            <a:avLst/>
-          </a:prstGeom>
-          <a:noFill/>
-          <a:ln/>
-        </p:spPr>
-        <p:txBody>
-          <a:bodyPr wrap="square" lIns="0" tIns="0" rIns="0" bIns="0" rtlCol="0" anchor="ctr"/>
-          <a:lstStyle/>
-          <a:p>
-            <a:pPr marL="0" indent="0" algn="ctr">
-              <a:buNone/>
-            </a:pPr>
-            <a:r>
-              <a:rPr lang="en-US" sz="900" dirty="0">
-                <a:solidFill>
-                  <a:srgbClr val="4A5568"/>
-                </a:solidFill>
-                <a:latin typeface="Calibri" pitchFamily="34" charset="0"/>
-                <a:ea typeface="Calibri" pitchFamily="34" charset="-122"/>
-                <a:cs typeface="Calibri" pitchFamily="34" charset="-120"/>
-              </a:rPr>
-              <a:t>← Predicted</a:t>
-            </a:r>
-            <a:endParaRPr lang="en-US" sz="900" dirty="0"/>
-          </a:p>
-        </p:txBody>
-      </p:sp>
-      <p:sp>
-        <p:nvSpPr>
           <p:cNvPr id="135" name="Shape 133"/>
           <p:cNvSpPr/>
           <p:nvPr/>
         </p:nvSpPr>
         <p:spPr>
           <a:xfrm>
-            <a:off x="4800600" y="4187952"/>
-            <a:ext cx="4023360" cy="475488"/>
+            <a:off x="320040" y="4586327"/>
+            <a:ext cx="5852160" cy="475488"/>
           </a:xfrm>
           <a:prstGeom prst="rect">
             <a:avLst/>
@@ -7350,8 +6896,8 @@
         </p:nvSpPr>
         <p:spPr>
           <a:xfrm>
-            <a:off x="4892040" y="4187952"/>
-            <a:ext cx="3840480" cy="475488"/>
+            <a:off x="411480" y="4586327"/>
+            <a:ext cx="3321627" cy="475488"/>
           </a:xfrm>
           <a:prstGeom prst="rect">
             <a:avLst/>
@@ -7376,23 +6922,6 @@
                 <a:cs typeface="Calibri" pitchFamily="34" charset="-120"/>
               </a:rPr>
               <a:t>Val set: Acc = 95.1%  |  Macro F1 = 94.5%  (n=41)</a:t>
-            </a:r>
-            <a:endParaRPr lang="en-US" sz="1100" dirty="0"/>
-          </a:p>
-          <a:p>
-            <a:pPr marL="0" indent="0" algn="l">
-              <a:buNone/>
-            </a:pPr>
-            <a:r>
-              <a:rPr lang="en-US" sz="1100" dirty="0">
-                <a:solidFill>
-                  <a:srgbClr val="065A82"/>
-                </a:solidFill>
-                <a:latin typeface="Calibri" pitchFamily="34" charset="0"/>
-                <a:ea typeface="Calibri" pitchFamily="34" charset="-122"/>
-                <a:cs typeface="Calibri" pitchFamily="34" charset="-120"/>
-              </a:rPr>
-              <a:t>Test set: Acc = 89.1%  |  Macro F1 = 87.7%  (n=46)</a:t>
             </a:r>
             <a:endParaRPr lang="en-US" sz="1100" dirty="0"/>
           </a:p>
@@ -7420,14 +6949,206 @@
         </p:blipFill>
         <p:spPr>
           <a:xfrm>
-            <a:off x="4892041" y="1673351"/>
-            <a:ext cx="2247755" cy="2285087"/>
+            <a:off x="3356681" y="2020824"/>
+            <a:ext cx="2250000" cy="2287369"/>
           </a:xfrm>
           <a:prstGeom prst="rect">
             <a:avLst/>
           </a:prstGeom>
         </p:spPr>
       </p:pic>
+      <p:sp>
+        <p:nvSpPr>
+          <p:cNvPr id="85" name="Text 134">
+            <a:extLst>
+              <a:ext uri="{FF2B5EF4-FFF2-40B4-BE49-F238E27FC236}">
+                <a16:creationId xmlns:a16="http://schemas.microsoft.com/office/drawing/2014/main" id="{46E0251F-483D-B44C-869D-9AAF5D4E8100}"/>
+              </a:ext>
+            </a:extLst>
+          </p:cNvPr>
+          <p:cNvSpPr/>
+          <p:nvPr/>
+        </p:nvSpPr>
+        <p:spPr>
+          <a:xfrm>
+            <a:off x="3307773" y="4592269"/>
+            <a:ext cx="3321627" cy="475488"/>
+          </a:xfrm>
+          <a:prstGeom prst="rect">
+            <a:avLst/>
+          </a:prstGeom>
+          <a:noFill/>
+          <a:ln/>
+        </p:spPr>
+        <p:txBody>
+          <a:bodyPr wrap="square" lIns="0" tIns="0" rIns="0" bIns="0" rtlCol="0" anchor="ctr"/>
+          <a:lstStyle/>
+          <a:p>
+            <a:pPr marL="0" indent="0" algn="l">
+              <a:buNone/>
+            </a:pPr>
+            <a:r>
+              <a:rPr lang="en-US" sz="1100" dirty="0">
+                <a:solidFill>
+                  <a:srgbClr val="065A82"/>
+                </a:solidFill>
+                <a:latin typeface="Calibri" pitchFamily="34" charset="0"/>
+                <a:ea typeface="Calibri" pitchFamily="34" charset="-122"/>
+                <a:cs typeface="Calibri" pitchFamily="34" charset="-120"/>
+              </a:rPr>
+              <a:t>Test set: Acc = 89.1%  |  Macro F1 = 87.7%  (n=46)</a:t>
+            </a:r>
+            <a:endParaRPr lang="en-US" sz="1100" dirty="0"/>
+          </a:p>
+        </p:txBody>
+      </p:sp>
+      <p:pic>
+        <p:nvPicPr>
+          <p:cNvPr id="88" name="圖片 87">
+            <a:extLst>
+              <a:ext uri="{FF2B5EF4-FFF2-40B4-BE49-F238E27FC236}">
+                <a16:creationId xmlns:a16="http://schemas.microsoft.com/office/drawing/2014/main" id="{C6C4D15D-6FAD-7A02-BC09-B8A02F8610B1}"/>
+              </a:ext>
+            </a:extLst>
+          </p:cNvPr>
+          <p:cNvPicPr>
+            <a:picLocks noChangeAspect="1"/>
+          </p:cNvPicPr>
+          <p:nvPr/>
+        </p:nvPicPr>
+        <p:blipFill>
+          <a:blip r:embed="rId4"/>
+          <a:stretch>
+            <a:fillRect/>
+          </a:stretch>
+        </p:blipFill>
+        <p:spPr>
+          <a:xfrm>
+            <a:off x="316230" y="2053157"/>
+            <a:ext cx="2249261" cy="2285087"/>
+          </a:xfrm>
+          <a:prstGeom prst="rect">
+            <a:avLst/>
+          </a:prstGeom>
+        </p:spPr>
+      </p:pic>
+      <p:sp>
+        <p:nvSpPr>
+          <p:cNvPr id="89" name="Text 82">
+            <a:extLst>
+              <a:ext uri="{FF2B5EF4-FFF2-40B4-BE49-F238E27FC236}">
+                <a16:creationId xmlns:a16="http://schemas.microsoft.com/office/drawing/2014/main" id="{0A0FA920-A048-F16B-26DA-4BA0D9F18B6F}"/>
+              </a:ext>
+            </a:extLst>
+          </p:cNvPr>
+          <p:cNvSpPr/>
+          <p:nvPr/>
+        </p:nvSpPr>
+        <p:spPr>
+          <a:xfrm>
+            <a:off x="316230" y="4338244"/>
+            <a:ext cx="4023360" cy="292608"/>
+          </a:xfrm>
+          <a:prstGeom prst="rect">
+            <a:avLst/>
+          </a:prstGeom>
+          <a:noFill/>
+          <a:ln/>
+        </p:spPr>
+        <p:txBody>
+          <a:bodyPr wrap="square" lIns="0" tIns="0" rIns="0" bIns="0" rtlCol="0" anchor="ctr"/>
+          <a:lstStyle/>
+          <a:p>
+            <a:pPr marL="0" indent="0" algn="l">
+              <a:buNone/>
+            </a:pPr>
+            <a:r>
+              <a:rPr lang="en-US" sz="1200" b="1" dirty="0">
+                <a:solidFill>
+                  <a:srgbClr val="065A82"/>
+                </a:solidFill>
+                <a:latin typeface="Calibri" pitchFamily="34" charset="0"/>
+                <a:ea typeface="Calibri" pitchFamily="34" charset="-122"/>
+                <a:cs typeface="Calibri" pitchFamily="34" charset="-120"/>
+              </a:rPr>
+              <a:t>Confusion Matrix — </a:t>
+            </a:r>
+            <a:r>
+              <a:rPr lang="en-US" altLang="zh-TW" sz="1200" b="1" dirty="0">
+                <a:solidFill>
+                  <a:srgbClr val="065A82"/>
+                </a:solidFill>
+                <a:latin typeface="Calibri" pitchFamily="34" charset="0"/>
+                <a:ea typeface="Calibri" pitchFamily="34" charset="-122"/>
+                <a:cs typeface="Calibri" pitchFamily="34" charset="-120"/>
+              </a:rPr>
+              <a:t>Val</a:t>
+            </a:r>
+            <a:r>
+              <a:rPr lang="en-US" sz="1200" b="1" dirty="0">
+                <a:solidFill>
+                  <a:srgbClr val="065A82"/>
+                </a:solidFill>
+                <a:latin typeface="Calibri" pitchFamily="34" charset="0"/>
+                <a:ea typeface="Calibri" pitchFamily="34" charset="-122"/>
+                <a:cs typeface="Calibri" pitchFamily="34" charset="-120"/>
+              </a:rPr>
+              <a:t> Set  (Acc = 95.1%%)</a:t>
+            </a:r>
+            <a:endParaRPr lang="en-US" sz="1200" dirty="0"/>
+          </a:p>
+        </p:txBody>
+      </p:sp>
+      <p:sp>
+        <p:nvSpPr>
+          <p:cNvPr id="22" name="Shape 20"/>
+          <p:cNvSpPr/>
+          <p:nvPr/>
+        </p:nvSpPr>
+        <p:spPr>
+          <a:xfrm>
+            <a:off x="6172200" y="2027643"/>
+            <a:ext cx="685800" cy="264107"/>
+          </a:xfrm>
+          <a:prstGeom prst="rect">
+            <a:avLst/>
+          </a:prstGeom>
+          <a:solidFill>
+            <a:srgbClr val="0A2342"/>
+          </a:solidFill>
+          <a:ln w="12700">
+            <a:solidFill>
+              <a:srgbClr val="0A2342"/>
+            </a:solidFill>
+            <a:prstDash val="solid"/>
+          </a:ln>
+        </p:spPr>
+        <p:txBody>
+          <a:bodyPr/>
+          <a:lstStyle/>
+          <a:p>
+            <a:pPr algn="ctr"/>
+            <a:r>
+              <a:rPr lang="en-US" altLang="zh-TW" sz="1000" b="1" dirty="0">
+                <a:solidFill>
+                  <a:srgbClr val="FFFFFF"/>
+                </a:solidFill>
+                <a:latin typeface="Calibri" pitchFamily="34" charset="0"/>
+                <a:ea typeface="Calibri" pitchFamily="34" charset="-122"/>
+                <a:cs typeface="Calibri" pitchFamily="34" charset="-120"/>
+              </a:rPr>
+              <a:t>test</a:t>
+            </a:r>
+            <a:endParaRPr lang="zh-TW" altLang="en-US" sz="1000" b="1" dirty="0">
+              <a:solidFill>
+                <a:srgbClr val="FFFFFF"/>
+              </a:solidFill>
+              <a:latin typeface="Calibri" pitchFamily="34" charset="0"/>
+              <a:cs typeface="Calibri" pitchFamily="34" charset="-120"/>
+            </a:endParaRPr>
+          </a:p>
+        </p:txBody>
+      </p:sp>
     </p:spTree>
   </p:cSld>
   <p:clrMapOvr>
@@ -8163,7 +7884,29 @@
                 <a:ea typeface="Calibri" pitchFamily="34" charset="-122"/>
                 <a:cs typeface="Calibri" pitchFamily="34" charset="-120"/>
               </a:rPr>
-              <a:t>分期預測</a:t>
+              <a:t>分</a:t>
+            </a:r>
+            <a:r>
+              <a:rPr lang="zh-TW" altLang="en-US" sz="1300" b="1" dirty="0">
+                <a:solidFill>
+                  <a:srgbClr val="1A202C"/>
+                </a:solidFill>
+                <a:latin typeface="Calibri" pitchFamily="34" charset="0"/>
+                <a:ea typeface="Calibri" pitchFamily="34" charset="-122"/>
+                <a:cs typeface="Calibri" pitchFamily="34" charset="-120"/>
+              </a:rPr>
+              <a:t>級</a:t>
+            </a:r>
+            <a:r>
+              <a:rPr lang="en-US" sz="1300" b="1" dirty="0" err="1">
+                <a:solidFill>
+                  <a:srgbClr val="1A202C"/>
+                </a:solidFill>
+                <a:latin typeface="Calibri" pitchFamily="34" charset="0"/>
+                <a:ea typeface="Calibri" pitchFamily="34" charset="-122"/>
+                <a:cs typeface="Calibri" pitchFamily="34" charset="-120"/>
+              </a:rPr>
+              <a:t>預測</a:t>
             </a:r>
             <a:endParaRPr lang="en-US" sz="1300" dirty="0"/>
           </a:p>
@@ -10174,13 +9917,13 @@
       </p:sp>
       <p:sp>
         <p:nvSpPr>
-          <p:cNvPr id="8" name="Shape 6"/>
-          <p:cNvSpPr/>
-          <p:nvPr/>
-        </p:nvSpPr>
-        <p:spPr>
-          <a:xfrm>
-            <a:off x="502920" y="1170432"/>
+          <p:cNvPr id="12" name="Shape 10"/>
+          <p:cNvSpPr/>
+          <p:nvPr/>
+        </p:nvSpPr>
+        <p:spPr>
+          <a:xfrm>
+            <a:off x="502920" y="1207008"/>
             <a:ext cx="3840480" cy="960120"/>
           </a:xfrm>
           <a:prstGeom prst="rect">
@@ -10199,13 +9942,13 @@
       </p:sp>
       <p:sp>
         <p:nvSpPr>
-          <p:cNvPr id="9" name="Shape 7"/>
-          <p:cNvSpPr/>
-          <p:nvPr/>
-        </p:nvSpPr>
-        <p:spPr>
-          <a:xfrm>
-            <a:off x="502920" y="1170432"/>
+          <p:cNvPr id="13" name="Shape 11"/>
+          <p:cNvSpPr/>
+          <p:nvPr/>
+        </p:nvSpPr>
+        <p:spPr>
+          <a:xfrm>
+            <a:off x="502920" y="1207008"/>
             <a:ext cx="54864" cy="960120"/>
           </a:xfrm>
           <a:prstGeom prst="rect">
@@ -10224,13 +9967,13 @@
       </p:sp>
       <p:sp>
         <p:nvSpPr>
-          <p:cNvPr id="10" name="Text 8"/>
-          <p:cNvSpPr/>
-          <p:nvPr/>
-        </p:nvSpPr>
-        <p:spPr>
-          <a:xfrm>
-            <a:off x="640080" y="1207008"/>
+          <p:cNvPr id="14" name="Text 12"/>
+          <p:cNvSpPr/>
+          <p:nvPr/>
+        </p:nvSpPr>
+        <p:spPr>
+          <a:xfrm>
+            <a:off x="640080" y="1243584"/>
             <a:ext cx="3657600" cy="274320"/>
           </a:xfrm>
           <a:prstGeom prst="rect">
@@ -10255,7 +9998,7 @@
                 <a:ea typeface="Calibri" pitchFamily="34" charset="-122"/>
                 <a:cs typeface="Calibri" pitchFamily="34" charset="-120"/>
               </a:rPr>
-              <a:t>Stage 2/3 辨識挑戰</a:t>
+              <a:t>Stacking 策略成效</a:t>
             </a:r>
             <a:endParaRPr lang="en-US" sz="1250" dirty="0"/>
           </a:p>
@@ -10263,13 +10006,13 @@
       </p:sp>
       <p:sp>
         <p:nvSpPr>
-          <p:cNvPr id="11" name="Text 9"/>
-          <p:cNvSpPr/>
-          <p:nvPr/>
-        </p:nvSpPr>
-        <p:spPr>
-          <a:xfrm>
-            <a:off x="640080" y="1481328"/>
+          <p:cNvPr id="15" name="Text 13"/>
+          <p:cNvSpPr/>
+          <p:nvPr/>
+        </p:nvSpPr>
+        <p:spPr>
+          <a:xfrm>
+            <a:off x="640080" y="1517904"/>
             <a:ext cx="3657600" cy="548640"/>
           </a:xfrm>
           <a:prstGeom prst="rect">
@@ -10294,7 +10037,40 @@
                 <a:ea typeface="Calibri" pitchFamily="34" charset="-122"/>
                 <a:cs typeface="Calibri" pitchFamily="34" charset="-120"/>
               </a:rPr>
-              <a:t>兩期特徵相近，需引入更多影像切面（正位+側位）或 MRI 資訊輔助</a:t>
+              <a:t>Ensemble 在 Stage 1 </a:t>
+            </a:r>
+            <a:r>
+              <a:rPr lang="en-US" sz="1150" dirty="0" err="1">
+                <a:solidFill>
+                  <a:srgbClr val="4A5568"/>
+                </a:solidFill>
+                <a:latin typeface="Calibri" pitchFamily="34" charset="0"/>
+                <a:ea typeface="Calibri" pitchFamily="34" charset="-122"/>
+                <a:cs typeface="Calibri" pitchFamily="34" charset="-120"/>
+              </a:rPr>
+              <a:t>偵測顯示優勢</a:t>
+            </a:r>
+            <a:r>
+              <a:rPr lang="en-US" sz="1150" dirty="0">
+                <a:solidFill>
+                  <a:srgbClr val="4A5568"/>
+                </a:solidFill>
+                <a:latin typeface="Calibri" pitchFamily="34" charset="0"/>
+                <a:ea typeface="Calibri" pitchFamily="34" charset="-122"/>
+                <a:cs typeface="Calibri" pitchFamily="34" charset="-120"/>
+              </a:rPr>
+              <a:t>，</a:t>
+            </a:r>
+            <a:r>
+              <a:rPr lang="zh-TW" altLang="en-US" sz="1150" dirty="0">
+                <a:solidFill>
+                  <a:srgbClr val="4A5568"/>
+                </a:solidFill>
+                <a:latin typeface="Calibri" pitchFamily="34" charset="0"/>
+                <a:ea typeface="Calibri" pitchFamily="34" charset="-122"/>
+                <a:cs typeface="Calibri" pitchFamily="34" charset="-120"/>
+              </a:rPr>
+              <a:t>各取所長能夠彌補單一模型架構的不足</a:t>
             </a:r>
             <a:endParaRPr lang="en-US" sz="1150" dirty="0"/>
           </a:p>
@@ -10302,13 +10078,13 @@
       </p:sp>
       <p:sp>
         <p:nvSpPr>
-          <p:cNvPr id="12" name="Shape 10"/>
-          <p:cNvSpPr/>
-          <p:nvPr/>
-        </p:nvSpPr>
-        <p:spPr>
-          <a:xfrm>
-            <a:off x="502920" y="2249424"/>
+          <p:cNvPr id="16" name="Shape 14"/>
+          <p:cNvSpPr/>
+          <p:nvPr/>
+        </p:nvSpPr>
+        <p:spPr>
+          <a:xfrm>
+            <a:off x="502920" y="2331720"/>
             <a:ext cx="3840480" cy="960120"/>
           </a:xfrm>
           <a:prstGeom prst="rect">
@@ -10327,13 +10103,13 @@
       </p:sp>
       <p:sp>
         <p:nvSpPr>
-          <p:cNvPr id="13" name="Shape 11"/>
-          <p:cNvSpPr/>
-          <p:nvPr/>
-        </p:nvSpPr>
-        <p:spPr>
-          <a:xfrm>
-            <a:off x="502920" y="2249424"/>
+          <p:cNvPr id="17" name="Shape 15"/>
+          <p:cNvSpPr/>
+          <p:nvPr/>
+        </p:nvSpPr>
+        <p:spPr>
+          <a:xfrm>
+            <a:off x="502920" y="2331720"/>
             <a:ext cx="54864" cy="960120"/>
           </a:xfrm>
           <a:prstGeom prst="rect">
@@ -10352,13 +10128,13 @@
       </p:sp>
       <p:sp>
         <p:nvSpPr>
-          <p:cNvPr id="14" name="Text 12"/>
-          <p:cNvSpPr/>
-          <p:nvPr/>
-        </p:nvSpPr>
-        <p:spPr>
-          <a:xfrm>
-            <a:off x="640080" y="2286000"/>
+          <p:cNvPr id="18" name="Text 16"/>
+          <p:cNvSpPr/>
+          <p:nvPr/>
+        </p:nvSpPr>
+        <p:spPr>
+          <a:xfrm>
+            <a:off x="640080" y="2368296"/>
             <a:ext cx="3657600" cy="274320"/>
           </a:xfrm>
           <a:prstGeom prst="rect">
@@ -10383,7 +10159,7 @@
                 <a:ea typeface="Calibri" pitchFamily="34" charset="-122"/>
                 <a:cs typeface="Calibri" pitchFamily="34" charset="-120"/>
               </a:rPr>
-              <a:t>Stacking 策略成效</a:t>
+              <a:t>Grad-CAM 醫學驗證</a:t>
             </a:r>
             <a:endParaRPr lang="en-US" sz="1250" dirty="0"/>
           </a:p>
@@ -10391,13 +10167,13 @@
       </p:sp>
       <p:sp>
         <p:nvSpPr>
-          <p:cNvPr id="15" name="Text 13"/>
-          <p:cNvSpPr/>
-          <p:nvPr/>
-        </p:nvSpPr>
-        <p:spPr>
-          <a:xfrm>
-            <a:off x="640080" y="2560320"/>
+          <p:cNvPr id="19" name="Text 17"/>
+          <p:cNvSpPr/>
+          <p:nvPr/>
+        </p:nvSpPr>
+        <p:spPr>
+          <a:xfrm>
+            <a:off x="640080" y="2642616"/>
             <a:ext cx="3657600" cy="548640"/>
           </a:xfrm>
           <a:prstGeom prst="rect">
@@ -10414,6 +10190,28 @@
               <a:buNone/>
             </a:pPr>
             <a:r>
+              <a:rPr lang="en-US" sz="1150" dirty="0" err="1">
+                <a:solidFill>
+                  <a:srgbClr val="4A5568"/>
+                </a:solidFill>
+                <a:latin typeface="Calibri" pitchFamily="34" charset="0"/>
+                <a:ea typeface="Calibri" pitchFamily="34" charset="-122"/>
+                <a:cs typeface="Calibri" pitchFamily="34" charset="-120"/>
+              </a:rPr>
+              <a:t>熱力圖</a:t>
+            </a:r>
+            <a:r>
+              <a:rPr lang="zh-TW" altLang="en-US" sz="1150" dirty="0">
+                <a:solidFill>
+                  <a:srgbClr val="4A5568"/>
+                </a:solidFill>
+                <a:latin typeface="Calibri" pitchFamily="34" charset="0"/>
+                <a:ea typeface="Calibri" pitchFamily="34" charset="-122"/>
+                <a:cs typeface="Calibri" pitchFamily="34" charset="-120"/>
+              </a:rPr>
+              <a:t>觀察位置</a:t>
+            </a:r>
+            <a:r>
               <a:rPr lang="en-US" sz="1150" dirty="0">
                 <a:solidFill>
                   <a:srgbClr val="4A5568"/>
@@ -10422,7 +10220,7 @@
                 <a:ea typeface="Calibri" pitchFamily="34" charset="-122"/>
                 <a:cs typeface="Calibri" pitchFamily="34" charset="-120"/>
               </a:rPr>
-              <a:t>Ensemble 在 Stage 1 </a:t>
+              <a:t>，</a:t>
             </a:r>
             <a:r>
               <a:rPr lang="en-US" sz="1150" dirty="0" err="1">
@@ -10433,157 +10231,7 @@
                 <a:ea typeface="Calibri" pitchFamily="34" charset="-122"/>
                 <a:cs typeface="Calibri" pitchFamily="34" charset="-120"/>
               </a:rPr>
-              <a:t>偵測顯示優勢，說明單一架構</a:t>
-            </a:r>
-            <a:r>
-              <a:rPr lang="zh-TW" altLang="en-US" sz="1150" dirty="0">
-                <a:solidFill>
-                  <a:srgbClr val="4A5568"/>
-                </a:solidFill>
-                <a:latin typeface="Calibri" pitchFamily="34" charset="0"/>
-                <a:ea typeface="Calibri" pitchFamily="34" charset="-122"/>
-                <a:cs typeface="Calibri" pitchFamily="34" charset="-120"/>
-              </a:rPr>
-              <a:t>的</a:t>
-            </a:r>
-            <a:r>
-              <a:rPr lang="en-US" sz="1150" dirty="0" err="1">
-                <a:solidFill>
-                  <a:srgbClr val="4A5568"/>
-                </a:solidFill>
-                <a:latin typeface="Calibri" pitchFamily="34" charset="0"/>
-                <a:ea typeface="Calibri" pitchFamily="34" charset="-122"/>
-                <a:cs typeface="Calibri" pitchFamily="34" charset="-120"/>
-              </a:rPr>
-              <a:t>不穩定性</a:t>
-            </a:r>
-            <a:endParaRPr lang="en-US" sz="1150" dirty="0"/>
-          </a:p>
-        </p:txBody>
-      </p:sp>
-      <p:sp>
-        <p:nvSpPr>
-          <p:cNvPr id="16" name="Shape 14"/>
-          <p:cNvSpPr/>
-          <p:nvPr/>
-        </p:nvSpPr>
-        <p:spPr>
-          <a:xfrm>
-            <a:off x="502920" y="3328416"/>
-            <a:ext cx="3840480" cy="960120"/>
-          </a:xfrm>
-          <a:prstGeom prst="rect">
-            <a:avLst/>
-          </a:prstGeom>
-          <a:solidFill>
-            <a:srgbClr val="EDF2F7"/>
-          </a:solidFill>
-          <a:ln w="6350">
-            <a:solidFill>
-              <a:srgbClr val="E2E8F0"/>
-            </a:solidFill>
-            <a:prstDash val="solid"/>
-          </a:ln>
-        </p:spPr>
-      </p:sp>
-      <p:sp>
-        <p:nvSpPr>
-          <p:cNvPr id="17" name="Shape 15"/>
-          <p:cNvSpPr/>
-          <p:nvPr/>
-        </p:nvSpPr>
-        <p:spPr>
-          <a:xfrm>
-            <a:off x="502920" y="3328416"/>
-            <a:ext cx="54864" cy="960120"/>
-          </a:xfrm>
-          <a:prstGeom prst="rect">
-            <a:avLst/>
-          </a:prstGeom>
-          <a:solidFill>
-            <a:srgbClr val="02C39A"/>
-          </a:solidFill>
-          <a:ln w="12700">
-            <a:solidFill>
-              <a:srgbClr val="02C39A"/>
-            </a:solidFill>
-            <a:prstDash val="solid"/>
-          </a:ln>
-        </p:spPr>
-      </p:sp>
-      <p:sp>
-        <p:nvSpPr>
-          <p:cNvPr id="18" name="Text 16"/>
-          <p:cNvSpPr/>
-          <p:nvPr/>
-        </p:nvSpPr>
-        <p:spPr>
-          <a:xfrm>
-            <a:off x="640080" y="3364992"/>
-            <a:ext cx="3657600" cy="274320"/>
-          </a:xfrm>
-          <a:prstGeom prst="rect">
-            <a:avLst/>
-          </a:prstGeom>
-          <a:noFill/>
-          <a:ln/>
-        </p:spPr>
-        <p:txBody>
-          <a:bodyPr wrap="square" lIns="0" tIns="0" rIns="0" bIns="0" rtlCol="0" anchor="ctr"/>
-          <a:lstStyle/>
-          <a:p>
-            <a:pPr marL="0" indent="0" algn="l">
-              <a:buNone/>
-            </a:pPr>
-            <a:r>
-              <a:rPr lang="en-US" sz="1250" b="1" dirty="0">
-                <a:solidFill>
-                  <a:srgbClr val="065A82"/>
-                </a:solidFill>
-                <a:latin typeface="Calibri" pitchFamily="34" charset="0"/>
-                <a:ea typeface="Calibri" pitchFamily="34" charset="-122"/>
-                <a:cs typeface="Calibri" pitchFamily="34" charset="-120"/>
-              </a:rPr>
-              <a:t>Grad-CAM 醫學驗證</a:t>
-            </a:r>
-            <a:endParaRPr lang="en-US" sz="1250" dirty="0"/>
-          </a:p>
-        </p:txBody>
-      </p:sp>
-      <p:sp>
-        <p:nvSpPr>
-          <p:cNvPr id="19" name="Text 17"/>
-          <p:cNvSpPr/>
-          <p:nvPr/>
-        </p:nvSpPr>
-        <p:spPr>
-          <a:xfrm>
-            <a:off x="640080" y="3639312"/>
-            <a:ext cx="3657600" cy="548640"/>
-          </a:xfrm>
-          <a:prstGeom prst="rect">
-            <a:avLst/>
-          </a:prstGeom>
-          <a:noFill/>
-          <a:ln/>
-        </p:spPr>
-        <p:txBody>
-          <a:bodyPr wrap="square" lIns="0" tIns="0" rIns="0" bIns="0" rtlCol="0" anchor="t"/>
-          <a:lstStyle/>
-          <a:p>
-            <a:pPr marL="0" indent="0" algn="l">
-              <a:buNone/>
-            </a:pPr>
-            <a:r>
-              <a:rPr lang="en-US" sz="1150" dirty="0">
-                <a:solidFill>
-                  <a:srgbClr val="4A5568"/>
-                </a:solidFill>
-                <a:latin typeface="Calibri" pitchFamily="34" charset="0"/>
-                <a:ea typeface="Calibri" pitchFamily="34" charset="-122"/>
-                <a:cs typeface="Calibri" pitchFamily="34" charset="-120"/>
-              </a:rPr>
-              <a:t>熱力圖與骨科醫師臨床觀察吻合，支持模型決策依據的合理性</a:t>
+              <a:t>支持模型決策依據的合理性</a:t>
             </a:r>
             <a:endParaRPr lang="en-US" sz="1150" dirty="0"/>
           </a:p>
@@ -10834,7 +10482,7 @@
         </p:nvSpPr>
         <p:spPr>
           <a:xfrm>
-            <a:off x="4800600" y="2011680"/>
+            <a:off x="4800600" y="1975104"/>
             <a:ext cx="320040" cy="320040"/>
           </a:xfrm>
           <a:prstGeom prst="ellipse">
@@ -10859,7 +10507,7 @@
         </p:nvSpPr>
         <p:spPr>
           <a:xfrm>
-            <a:off x="4800600" y="2011680"/>
+            <a:off x="4800600" y="1975104"/>
             <a:ext cx="320040" cy="320040"/>
           </a:xfrm>
           <a:prstGeom prst="rect">
@@ -10898,7 +10546,7 @@
         </p:nvSpPr>
         <p:spPr>
           <a:xfrm>
-            <a:off x="5212080" y="2011680"/>
+            <a:off x="5212080" y="1975104"/>
             <a:ext cx="3474720" cy="237744"/>
           </a:xfrm>
           <a:prstGeom prst="rect">
@@ -10923,7 +10571,7 @@
                 <a:ea typeface="Calibri" pitchFamily="34" charset="-122"/>
                 <a:cs typeface="Calibri" pitchFamily="34" charset="-120"/>
               </a:rPr>
-              <a:t>目前沒有健康的資料</a:t>
+              <a:t>目前沒有訓練健康的資料</a:t>
             </a:r>
           </a:p>
         </p:txBody>
@@ -10936,7 +10584,7 @@
         </p:nvSpPr>
         <p:spPr>
           <a:xfrm>
-            <a:off x="5212080" y="2249424"/>
+            <a:off x="5212080" y="2212848"/>
             <a:ext cx="3474720" cy="502920"/>
           </a:xfrm>
           <a:prstGeom prst="rect">
@@ -11073,9 +10721,6 @@
           <a:bodyPr wrap="square" lIns="0" tIns="0" rIns="0" bIns="0" rtlCol="0" anchor="ctr"/>
           <a:lstStyle/>
           <a:p>
-            <a:pPr marL="0" indent="0" algn="l">
-              <a:buNone/>
-            </a:pPr>
             <a:r>
               <a:rPr lang="zh-TW" altLang="en-US" sz="1250" b="1" dirty="0">
                 <a:solidFill>
@@ -11085,9 +10730,8 @@
                 <a:ea typeface="Calibri" pitchFamily="34" charset="-122"/>
                 <a:cs typeface="Calibri" pitchFamily="34" charset="-120"/>
               </a:rPr>
-              <a:t>前瞻性驗證待進行</a:t>
-            </a:r>
-            <a:endParaRPr lang="en-US" sz="1250" dirty="0"/>
+              <a:t>網站系統優化</a:t>
+            </a:r>
           </a:p>
         </p:txBody>
       </p:sp>
@@ -11112,9 +10756,6 @@
           <a:bodyPr wrap="square" lIns="0" tIns="0" rIns="0" bIns="0" rtlCol="0" anchor="t"/>
           <a:lstStyle/>
           <a:p>
-            <a:pPr marL="0" indent="0" algn="l">
-              <a:buNone/>
-            </a:pPr>
             <a:r>
               <a:rPr lang="zh-TW" altLang="en-US" sz="1100" dirty="0">
                 <a:solidFill>
@@ -11124,14 +10765,14 @@
                 <a:ea typeface="Calibri" pitchFamily="34" charset="-122"/>
                 <a:cs typeface="Calibri" pitchFamily="34" charset="-120"/>
               </a:rPr>
-              <a:t>需要在真實臨床流程中進行前瞻性驗證，評估臨床實際效益</a:t>
-            </a:r>
-          </a:p>
-        </p:txBody>
-      </p:sp>
-      <p:sp>
-        <p:nvSpPr>
-          <p:cNvPr id="35" name="Shape 33"/>
+              <a:t>尚不能一次匯入大量圖片，希望一次能匯入數張圖片，更有效率幫助醫生</a:t>
+            </a:r>
+          </a:p>
+        </p:txBody>
+      </p:sp>
+      <p:sp>
+        <p:nvSpPr>
+          <p:cNvPr id="36" name="Text 34"/>
           <p:cNvSpPr/>
           <p:nvPr/>
         </p:nvSpPr>
@@ -11140,31 +10781,6 @@
             <a:off x="4800600" y="3621024"/>
             <a:ext cx="320040" cy="320040"/>
           </a:xfrm>
-          <a:prstGeom prst="ellipse">
-            <a:avLst/>
-          </a:prstGeom>
-          <a:solidFill>
-            <a:srgbClr val="7B341E"/>
-          </a:solidFill>
-          <a:ln w="12700">
-            <a:solidFill>
-              <a:srgbClr val="7B341E"/>
-            </a:solidFill>
-            <a:prstDash val="solid"/>
-          </a:ln>
-        </p:spPr>
-      </p:sp>
-      <p:sp>
-        <p:nvSpPr>
-          <p:cNvPr id="36" name="Text 34"/>
-          <p:cNvSpPr/>
-          <p:nvPr/>
-        </p:nvSpPr>
-        <p:spPr>
-          <a:xfrm>
-            <a:off x="4800600" y="3621024"/>
-            <a:ext cx="320040" cy="320040"/>
-          </a:xfrm>
           <a:prstGeom prst="rect">
             <a:avLst/>
           </a:prstGeom>
@@ -11217,17 +10833,14 @@
             <a:pPr marL="0" indent="0" algn="l">
               <a:buNone/>
             </a:pPr>
-            <a:r>
-              <a:rPr lang="zh-TW" altLang="en-US" sz="1250" b="1" dirty="0">
-                <a:solidFill>
-                  <a:srgbClr val="1A202C"/>
-                </a:solidFill>
-                <a:latin typeface="Calibri" pitchFamily="34" charset="0"/>
-                <a:ea typeface="Calibri" pitchFamily="34" charset="-122"/>
-                <a:cs typeface="Calibri" pitchFamily="34" charset="-120"/>
-              </a:rPr>
-              <a:t>網站系統優化</a:t>
-            </a:r>
+            <a:endParaRPr lang="zh-TW" altLang="en-US" sz="1250" b="1" dirty="0">
+              <a:solidFill>
+                <a:srgbClr val="1A202C"/>
+              </a:solidFill>
+              <a:latin typeface="Calibri" pitchFamily="34" charset="0"/>
+              <a:ea typeface="Calibri" pitchFamily="34" charset="-122"/>
+              <a:cs typeface="Calibri" pitchFamily="34" charset="-120"/>
+            </a:endParaRPr>
           </a:p>
         </p:txBody>
       </p:sp>
@@ -11255,17 +10868,14 @@
             <a:pPr marL="0" indent="0" algn="l">
               <a:buNone/>
             </a:pPr>
-            <a:r>
-              <a:rPr lang="zh-TW" altLang="en-US" sz="1100" dirty="0">
-                <a:solidFill>
-                  <a:srgbClr val="4A5568"/>
-                </a:solidFill>
-                <a:latin typeface="Calibri" pitchFamily="34" charset="0"/>
-                <a:ea typeface="Calibri" pitchFamily="34" charset="-122"/>
-                <a:cs typeface="Calibri" pitchFamily="34" charset="-120"/>
-              </a:rPr>
-              <a:t>希望一次能匯入數張圖片，更有效率幫助醫生</a:t>
-            </a:r>
+            <a:endParaRPr lang="zh-TW" altLang="en-US" sz="1100" dirty="0">
+              <a:solidFill>
+                <a:srgbClr val="4A5568"/>
+              </a:solidFill>
+              <a:latin typeface="Calibri" pitchFamily="34" charset="0"/>
+              <a:ea typeface="Calibri" pitchFamily="34" charset="-122"/>
+              <a:cs typeface="Calibri" pitchFamily="34" charset="-120"/>
+            </a:endParaRPr>
           </a:p>
         </p:txBody>
       </p:sp>
@@ -11474,7 +11084,51 @@
                 <a:ea typeface="Calibri" pitchFamily="34" charset="-122"/>
                 <a:cs typeface="Calibri" pitchFamily="34" charset="-120"/>
               </a:rPr>
-              <a:t>成功建立一套端對端髖關節 X 光影像 Ficat 分期 AI 系統，涵蓋 ROI </a:t>
+              <a:t>成功建立一套端對端髖關節 X 光影像 </a:t>
+            </a:r>
+            <a:r>
+              <a:rPr lang="en-US" sz="1400" b="1" dirty="0" err="1">
+                <a:solidFill>
+                  <a:srgbClr val="FFFFFF"/>
+                </a:solidFill>
+                <a:latin typeface="Calibri" pitchFamily="34" charset="0"/>
+                <a:ea typeface="Calibri" pitchFamily="34" charset="-122"/>
+                <a:cs typeface="Calibri" pitchFamily="34" charset="-120"/>
+              </a:rPr>
+              <a:t>Ficat</a:t>
+            </a:r>
+            <a:r>
+              <a:rPr lang="en-US" sz="1400" b="1" dirty="0">
+                <a:solidFill>
+                  <a:srgbClr val="FFFFFF"/>
+                </a:solidFill>
+                <a:latin typeface="Calibri" pitchFamily="34" charset="0"/>
+                <a:ea typeface="Calibri" pitchFamily="34" charset="-122"/>
+                <a:cs typeface="Calibri" pitchFamily="34" charset="-120"/>
+              </a:rPr>
+              <a:t> 分</a:t>
+            </a:r>
+            <a:r>
+              <a:rPr lang="zh-TW" altLang="en-US" sz="1400" b="1" dirty="0">
+                <a:solidFill>
+                  <a:srgbClr val="FFFFFF"/>
+                </a:solidFill>
+                <a:latin typeface="Calibri" pitchFamily="34" charset="0"/>
+                <a:ea typeface="Calibri" pitchFamily="34" charset="-122"/>
+                <a:cs typeface="Calibri" pitchFamily="34" charset="-120"/>
+              </a:rPr>
+              <a:t>級</a:t>
+            </a:r>
+            <a:r>
+              <a:rPr lang="en-US" sz="1400" b="1" dirty="0">
+                <a:solidFill>
+                  <a:srgbClr val="FFFFFF"/>
+                </a:solidFill>
+                <a:latin typeface="Calibri" pitchFamily="34" charset="0"/>
+                <a:ea typeface="Calibri" pitchFamily="34" charset="-122"/>
+                <a:cs typeface="Calibri" pitchFamily="34" charset="-120"/>
+              </a:rPr>
+              <a:t> AI 系統，涵蓋 ROI </a:t>
             </a:r>
             <a:r>
               <a:rPr lang="en-US" sz="1400" b="1" dirty="0" err="1">
@@ -12176,7 +11830,51 @@
                 <a:ea typeface="Calibri" pitchFamily="34" charset="-122"/>
                 <a:cs typeface="Calibri" pitchFamily="34" charset="-120"/>
               </a:rPr>
-              <a:t>· 提供髖關節 X 光 Ficat 分期深度學習基準方法</a:t>
+              <a:t>· 提供髖關節 X 光 </a:t>
+            </a:r>
+            <a:r>
+              <a:rPr lang="en-US" sz="1200" dirty="0" err="1">
+                <a:solidFill>
+                  <a:srgbClr val="CADCFC"/>
+                </a:solidFill>
+                <a:latin typeface="Calibri" pitchFamily="34" charset="0"/>
+                <a:ea typeface="Calibri" pitchFamily="34" charset="-122"/>
+                <a:cs typeface="Calibri" pitchFamily="34" charset="-120"/>
+              </a:rPr>
+              <a:t>Ficat</a:t>
+            </a:r>
+            <a:r>
+              <a:rPr lang="en-US" sz="1200" dirty="0">
+                <a:solidFill>
+                  <a:srgbClr val="CADCFC"/>
+                </a:solidFill>
+                <a:latin typeface="Calibri" pitchFamily="34" charset="0"/>
+                <a:ea typeface="Calibri" pitchFamily="34" charset="-122"/>
+                <a:cs typeface="Calibri" pitchFamily="34" charset="-120"/>
+              </a:rPr>
+              <a:t> 分</a:t>
+            </a:r>
+            <a:r>
+              <a:rPr lang="zh-TW" altLang="en-US" sz="1200" dirty="0">
+                <a:solidFill>
+                  <a:srgbClr val="CADCFC"/>
+                </a:solidFill>
+                <a:latin typeface="Calibri" pitchFamily="34" charset="0"/>
+                <a:ea typeface="Calibri" pitchFamily="34" charset="-122"/>
+                <a:cs typeface="Calibri" pitchFamily="34" charset="-120"/>
+              </a:rPr>
+              <a:t>級</a:t>
+            </a:r>
+            <a:r>
+              <a:rPr lang="en-US" sz="1200" dirty="0" err="1">
+                <a:solidFill>
+                  <a:srgbClr val="CADCFC"/>
+                </a:solidFill>
+                <a:latin typeface="Calibri" pitchFamily="34" charset="0"/>
+                <a:ea typeface="Calibri" pitchFamily="34" charset="-122"/>
+                <a:cs typeface="Calibri" pitchFamily="34" charset="-120"/>
+              </a:rPr>
+              <a:t>深度學習</a:t>
             </a:r>
             <a:endParaRPr lang="en-US" sz="1200" dirty="0"/>
           </a:p>
@@ -12216,45 +11914,6 @@
                 <a:cs typeface="Calibri" pitchFamily="34" charset="-120"/>
               </a:rPr>
               <a:t>· t-SNE 分析揭示各期特徵可分離性</a:t>
-            </a:r>
-            <a:endParaRPr lang="en-US" sz="1200" dirty="0"/>
-          </a:p>
-        </p:txBody>
-      </p:sp>
-      <p:sp>
-        <p:nvSpPr>
-          <p:cNvPr id="24" name="Text 22"/>
-          <p:cNvSpPr/>
-          <p:nvPr/>
-        </p:nvSpPr>
-        <p:spPr>
-          <a:xfrm>
-            <a:off x="6172200" y="3675888"/>
-            <a:ext cx="2377440" cy="548640"/>
-          </a:xfrm>
-          <a:prstGeom prst="rect">
-            <a:avLst/>
-          </a:prstGeom>
-          <a:noFill/>
-          <a:ln/>
-        </p:spPr>
-        <p:txBody>
-          <a:bodyPr wrap="square" lIns="0" tIns="0" rIns="0" bIns="0" rtlCol="0" anchor="ctr"/>
-          <a:lstStyle/>
-          <a:p>
-            <a:pPr marL="0" indent="0" algn="l">
-              <a:buNone/>
-            </a:pPr>
-            <a:r>
-              <a:rPr lang="en-US" sz="1200" dirty="0">
-                <a:solidFill>
-                  <a:srgbClr val="CADCFC"/>
-                </a:solidFill>
-                <a:latin typeface="Calibri" pitchFamily="34" charset="0"/>
-                <a:ea typeface="Calibri" pitchFamily="34" charset="-122"/>
-                <a:cs typeface="Calibri" pitchFamily="34" charset="-120"/>
-              </a:rPr>
-              <a:t>· 公開模型權重促進後續研究</a:t>
             </a:r>
             <a:endParaRPr lang="en-US" sz="1200" dirty="0"/>
           </a:p>
@@ -12693,7 +12352,51 @@
                 <a:ea typeface="Calibri" pitchFamily="34" charset="-122"/>
                 <a:cs typeface="Calibri" pitchFamily="34" charset="-120"/>
               </a:rPr>
-              <a:t>仁愛醫院 髖關節 Ficat 分期 Deep Learning Project  ·  2025</a:t>
+              <a:t>仁愛醫院 髖關節 </a:t>
+            </a:r>
+            <a:r>
+              <a:rPr lang="en-US" sz="1050" dirty="0" err="1">
+                <a:solidFill>
+                  <a:srgbClr val="4A6785"/>
+                </a:solidFill>
+                <a:latin typeface="Calibri" pitchFamily="34" charset="0"/>
+                <a:ea typeface="Calibri" pitchFamily="34" charset="-122"/>
+                <a:cs typeface="Calibri" pitchFamily="34" charset="-120"/>
+              </a:rPr>
+              <a:t>Ficat</a:t>
+            </a:r>
+            <a:r>
+              <a:rPr lang="en-US" sz="1050" dirty="0">
+                <a:solidFill>
+                  <a:srgbClr val="4A6785"/>
+                </a:solidFill>
+                <a:latin typeface="Calibri" pitchFamily="34" charset="0"/>
+                <a:ea typeface="Calibri" pitchFamily="34" charset="-122"/>
+                <a:cs typeface="Calibri" pitchFamily="34" charset="-120"/>
+              </a:rPr>
+              <a:t> 分</a:t>
+            </a:r>
+            <a:r>
+              <a:rPr lang="zh-TW" altLang="en-US" sz="1050" dirty="0">
+                <a:solidFill>
+                  <a:srgbClr val="4A6785"/>
+                </a:solidFill>
+                <a:latin typeface="Calibri" pitchFamily="34" charset="0"/>
+                <a:ea typeface="Calibri" pitchFamily="34" charset="-122"/>
+                <a:cs typeface="Calibri" pitchFamily="34" charset="-120"/>
+              </a:rPr>
+              <a:t>級</a:t>
+            </a:r>
+            <a:r>
+              <a:rPr lang="en-US" sz="1050" dirty="0">
+                <a:solidFill>
+                  <a:srgbClr val="4A6785"/>
+                </a:solidFill>
+                <a:latin typeface="Calibri" pitchFamily="34" charset="0"/>
+                <a:ea typeface="Calibri" pitchFamily="34" charset="-122"/>
+                <a:cs typeface="Calibri" pitchFamily="34" charset="-120"/>
+              </a:rPr>
+              <a:t> Deep Learning Project  ·  2025</a:t>
             </a:r>
             <a:endParaRPr lang="en-US" sz="1050" dirty="0"/>
           </a:p>
@@ -13376,7 +13079,40 @@
                 <a:ea typeface="Calibri" pitchFamily="34" charset="-122"/>
                 <a:cs typeface="Calibri" pitchFamily="34" charset="-120"/>
               </a:rPr>
-              <a:t>精準 Ficat 分期</a:t>
+              <a:t>精準 </a:t>
+            </a:r>
+            <a:r>
+              <a:rPr lang="en-US" sz="1300" b="1" dirty="0" err="1">
+                <a:solidFill>
+                  <a:srgbClr val="065A82"/>
+                </a:solidFill>
+                <a:latin typeface="Calibri" pitchFamily="34" charset="0"/>
+                <a:ea typeface="Calibri" pitchFamily="34" charset="-122"/>
+                <a:cs typeface="Calibri" pitchFamily="34" charset="-120"/>
+              </a:rPr>
+              <a:t>Ficat</a:t>
+            </a:r>
+            <a:r>
+              <a:rPr lang="en-US" sz="1300" b="1" dirty="0">
+                <a:solidFill>
+                  <a:srgbClr val="065A82"/>
+                </a:solidFill>
+                <a:latin typeface="Calibri" pitchFamily="34" charset="0"/>
+                <a:ea typeface="Calibri" pitchFamily="34" charset="-122"/>
+                <a:cs typeface="Calibri" pitchFamily="34" charset="-120"/>
+              </a:rPr>
+              <a:t> 分</a:t>
+            </a:r>
+            <a:r>
+              <a:rPr lang="zh-TW" altLang="en-US" sz="1300" b="1">
+                <a:solidFill>
+                  <a:srgbClr val="065A82"/>
+                </a:solidFill>
+                <a:latin typeface="Calibri" pitchFamily="34" charset="0"/>
+                <a:ea typeface="Calibri" pitchFamily="34" charset="-122"/>
+                <a:cs typeface="Calibri" pitchFamily="34" charset="-120"/>
+              </a:rPr>
+              <a:t>級</a:t>
             </a:r>
             <a:endParaRPr lang="en-US" sz="1300" dirty="0"/>
           </a:p>
@@ -13600,7 +13336,18 @@
                 <a:ea typeface="Calibri" pitchFamily="34" charset="-122"/>
                 <a:cs typeface="Calibri" pitchFamily="34" charset="-120"/>
               </a:rPr>
-              <a:t>透過 Grad-CAM 與 t-SNE 提供視覺化解釋，輔助醫師診斷</a:t>
+              <a:t>透過 Grad-CAM </a:t>
+            </a:r>
+            <a:r>
+              <a:rPr lang="en-US" sz="1100" dirty="0" err="1">
+                <a:solidFill>
+                  <a:srgbClr val="4A5568"/>
+                </a:solidFill>
+                <a:latin typeface="Calibri" pitchFamily="34" charset="0"/>
+                <a:ea typeface="Calibri" pitchFamily="34" charset="-122"/>
+                <a:cs typeface="Calibri" pitchFamily="34" charset="-120"/>
+              </a:rPr>
+              <a:t>提供視覺化解釋，輔助醫師診斷</a:t>
             </a:r>
             <a:endParaRPr lang="en-US" sz="1100" dirty="0"/>
           </a:p>
@@ -14219,7 +13966,29 @@
                 <a:ea typeface="Calibri" pitchFamily="34" charset="-122"/>
                 <a:cs typeface="Calibri" pitchFamily="34" charset="-120"/>
               </a:rPr>
-              <a:t>分期類別</a:t>
+              <a:t>分</a:t>
+            </a:r>
+            <a:r>
+              <a:rPr lang="zh-TW" altLang="en-US" sz="1300" b="1" dirty="0">
+                <a:solidFill>
+                  <a:srgbClr val="FFFFFF"/>
+                </a:solidFill>
+                <a:latin typeface="Calibri" pitchFamily="34" charset="0"/>
+                <a:ea typeface="Calibri" pitchFamily="34" charset="-122"/>
+                <a:cs typeface="Calibri" pitchFamily="34" charset="-120"/>
+              </a:rPr>
+              <a:t>級</a:t>
+            </a:r>
+            <a:r>
+              <a:rPr lang="en-US" sz="1300" b="1" dirty="0" err="1">
+                <a:solidFill>
+                  <a:srgbClr val="FFFFFF"/>
+                </a:solidFill>
+                <a:latin typeface="Calibri" pitchFamily="34" charset="0"/>
+                <a:ea typeface="Calibri" pitchFamily="34" charset="-122"/>
+                <a:cs typeface="Calibri" pitchFamily="34" charset="-120"/>
+              </a:rPr>
+              <a:t>類別</a:t>
             </a:r>
             <a:endParaRPr lang="en-US" sz="1300" dirty="0"/>
           </a:p>
@@ -14289,7 +14058,7 @@
               <a:buNone/>
             </a:pPr>
             <a:r>
-              <a:rPr lang="en-US" sz="1500" b="1" dirty="0">
+              <a:rPr lang="en-US" sz="1500" b="1" dirty="0" err="1">
                 <a:solidFill>
                   <a:srgbClr val="065A82"/>
                 </a:solidFill>
@@ -14297,7 +14066,29 @@
                 <a:ea typeface="Calibri" pitchFamily="34" charset="-122"/>
                 <a:cs typeface="Calibri" pitchFamily="34" charset="-120"/>
               </a:rPr>
-              <a:t>各分期資料分佈</a:t>
+              <a:t>各分</a:t>
+            </a:r>
+            <a:r>
+              <a:rPr lang="zh-TW" altLang="en-US" sz="1500" b="1" dirty="0">
+                <a:solidFill>
+                  <a:srgbClr val="065A82"/>
+                </a:solidFill>
+                <a:latin typeface="Calibri" pitchFamily="34" charset="0"/>
+                <a:ea typeface="Calibri" pitchFamily="34" charset="-122"/>
+                <a:cs typeface="Calibri" pitchFamily="34" charset="-120"/>
+              </a:rPr>
+              <a:t>級</a:t>
+            </a:r>
+            <a:r>
+              <a:rPr lang="en-US" sz="1500" b="1" dirty="0" err="1">
+                <a:solidFill>
+                  <a:srgbClr val="065A82"/>
+                </a:solidFill>
+                <a:latin typeface="Calibri" pitchFamily="34" charset="0"/>
+                <a:ea typeface="Calibri" pitchFamily="34" charset="-122"/>
+                <a:cs typeface="Calibri" pitchFamily="34" charset="-120"/>
+              </a:rPr>
+              <a:t>資料分佈</a:t>
             </a:r>
             <a:endParaRPr lang="en-US" sz="1500" dirty="0"/>
           </a:p>
@@ -16883,7 +16674,29 @@
                 <a:ea typeface="Calibri" pitchFamily="34" charset="-122"/>
                 <a:cs typeface="Calibri" pitchFamily="34" charset="-120"/>
               </a:rPr>
-              <a:t>分期結果</a:t>
+              <a:t>分</a:t>
+            </a:r>
+            <a:r>
+              <a:rPr lang="zh-TW" altLang="en-US" sz="1200" b="1" dirty="0">
+                <a:solidFill>
+                  <a:srgbClr val="FFFFFF"/>
+                </a:solidFill>
+                <a:latin typeface="Calibri" pitchFamily="34" charset="0"/>
+                <a:ea typeface="Calibri" pitchFamily="34" charset="-122"/>
+                <a:cs typeface="Calibri" pitchFamily="34" charset="-120"/>
+              </a:rPr>
+              <a:t>級</a:t>
+            </a:r>
+            <a:r>
+              <a:rPr lang="en-US" sz="1200" b="1" dirty="0" err="1">
+                <a:solidFill>
+                  <a:srgbClr val="FFFFFF"/>
+                </a:solidFill>
+                <a:latin typeface="Calibri" pitchFamily="34" charset="0"/>
+                <a:ea typeface="Calibri" pitchFamily="34" charset="-122"/>
+                <a:cs typeface="Calibri" pitchFamily="34" charset="-120"/>
+              </a:rPr>
+              <a:t>結果</a:t>
             </a:r>
             <a:endParaRPr lang="en-US" sz="1200" dirty="0"/>
           </a:p>
@@ -18483,29 +18296,6 @@
       </p:sp>
       <p:sp>
         <p:nvSpPr>
-          <p:cNvPr id="42" name="Shape 40"/>
-          <p:cNvSpPr/>
-          <p:nvPr/>
-        </p:nvSpPr>
-        <p:spPr>
-          <a:xfrm>
-            <a:off x="5010912" y="3493008"/>
-            <a:ext cx="0" cy="256032"/>
-          </a:xfrm>
-          <a:prstGeom prst="line">
-            <a:avLst/>
-          </a:prstGeom>
-          <a:noFill/>
-          <a:ln w="19050">
-            <a:solidFill>
-              <a:srgbClr val="CBD5E0"/>
-            </a:solidFill>
-            <a:prstDash val="solid"/>
-          </a:ln>
-        </p:spPr>
-      </p:sp>
-      <p:sp>
-        <p:nvSpPr>
           <p:cNvPr id="43" name="Text 41"/>
           <p:cNvSpPr/>
           <p:nvPr/>
@@ -18568,6 +18358,17 @@
               <a:buNone/>
             </a:pPr>
             <a:r>
+              <a:rPr lang="en-US" sz="1100" dirty="0" err="1">
+                <a:solidFill>
+                  <a:srgbClr val="4A5568"/>
+                </a:solidFill>
+                <a:latin typeface="Calibri" pitchFamily="34" charset="0"/>
+                <a:ea typeface="Calibri" pitchFamily="34" charset="-122"/>
+                <a:cs typeface="Calibri" pitchFamily="34" charset="-120"/>
+              </a:rPr>
+              <a:t>裁切並</a:t>
+            </a:r>
+            <a:r>
               <a:rPr lang="en-US" sz="1100" dirty="0">
                 <a:solidFill>
                   <a:srgbClr val="4A5568"/>
@@ -18576,18 +18377,7 @@
                 <a:ea typeface="Calibri" pitchFamily="34" charset="-122"/>
                 <a:cs typeface="Calibri" pitchFamily="34" charset="-120"/>
               </a:rPr>
-              <a:t>裁切並 resize 至</a:t>
-            </a:r>
-            <a:r>
-              <a:rPr lang="en-US" altLang="zh-TW" sz="1100" dirty="0">
-                <a:solidFill>
-                  <a:srgbClr val="4A5568"/>
-                </a:solidFill>
-                <a:latin typeface="Calibri" pitchFamily="34" charset="0"/>
-                <a:ea typeface="Calibri" pitchFamily="34" charset="-122"/>
-                <a:cs typeface="Calibri" pitchFamily="34" charset="-120"/>
-              </a:rPr>
-              <a:t>384×384</a:t>
+              <a:t> resize</a:t>
             </a:r>
             <a:endParaRPr lang="en-US" sz="1100" dirty="0"/>
           </a:p>
@@ -18595,7 +18385,7 @@
       </p:sp>
       <p:sp>
         <p:nvSpPr>
-          <p:cNvPr id="45" name="Shape 43"/>
+          <p:cNvPr id="46" name="Text 44"/>
           <p:cNvSpPr/>
           <p:nvPr/>
         </p:nvSpPr>
@@ -18604,31 +18394,6 @@
             <a:off x="4828032" y="3749040"/>
             <a:ext cx="365760" cy="365760"/>
           </a:xfrm>
-          <a:prstGeom prst="ellipse">
-            <a:avLst/>
-          </a:prstGeom>
-          <a:solidFill>
-            <a:srgbClr val="065A82"/>
-          </a:solidFill>
-          <a:ln w="12700">
-            <a:solidFill>
-              <a:srgbClr val="065A82"/>
-            </a:solidFill>
-            <a:prstDash val="solid"/>
-          </a:ln>
-        </p:spPr>
-      </p:sp>
-      <p:sp>
-        <p:nvSpPr>
-          <p:cNvPr id="46" name="Text 44"/>
-          <p:cNvSpPr/>
-          <p:nvPr/>
-        </p:nvSpPr>
-        <p:spPr>
-          <a:xfrm>
-            <a:off x="4828032" y="3749040"/>
-            <a:ext cx="365760" cy="365760"/>
-          </a:xfrm>
           <a:prstGeom prst="rect">
             <a:avLst/>
           </a:prstGeom>
@@ -18657,84 +18422,36 @@
           </a:p>
         </p:txBody>
       </p:sp>
-      <p:sp>
-        <p:nvSpPr>
-          <p:cNvPr id="47" name="Text 45"/>
-          <p:cNvSpPr/>
-          <p:nvPr/>
-        </p:nvSpPr>
-        <p:spPr>
-          <a:xfrm>
-            <a:off x="5321808" y="3749040"/>
-            <a:ext cx="3108960" cy="201168"/>
-          </a:xfrm>
-          <a:prstGeom prst="rect">
-            <a:avLst/>
-          </a:prstGeom>
-          <a:noFill/>
-          <a:ln/>
-        </p:spPr>
-        <p:txBody>
-          <a:bodyPr wrap="square" lIns="0" tIns="0" rIns="0" bIns="0" rtlCol="0" anchor="ctr"/>
-          <a:lstStyle/>
-          <a:p>
-            <a:pPr marL="0" indent="0" algn="l">
-              <a:buNone/>
-            </a:pPr>
-            <a:r>
-              <a:rPr lang="en-US" sz="1200" b="1" dirty="0">
-                <a:solidFill>
-                  <a:srgbClr val="1A202C"/>
-                </a:solidFill>
-                <a:latin typeface="Calibri" pitchFamily="34" charset="0"/>
-                <a:ea typeface="Calibri" pitchFamily="34" charset="-122"/>
-                <a:cs typeface="Calibri" pitchFamily="34" charset="-120"/>
-              </a:rPr>
-              <a:t>送入分類模型</a:t>
-            </a:r>
-            <a:endParaRPr lang="en-US" sz="1200" dirty="0"/>
-          </a:p>
-        </p:txBody>
-      </p:sp>
-      <p:sp>
-        <p:nvSpPr>
-          <p:cNvPr id="48" name="Text 46"/>
-          <p:cNvSpPr/>
-          <p:nvPr/>
-        </p:nvSpPr>
-        <p:spPr>
-          <a:xfrm>
-            <a:off x="5321808" y="3950208"/>
-            <a:ext cx="3108960" cy="182880"/>
-          </a:xfrm>
-          <a:prstGeom prst="rect">
-            <a:avLst/>
-          </a:prstGeom>
-          <a:noFill/>
-          <a:ln/>
-        </p:spPr>
-        <p:txBody>
-          <a:bodyPr wrap="square" lIns="0" tIns="0" rIns="0" bIns="0" rtlCol="0" anchor="ctr"/>
-          <a:lstStyle/>
-          <a:p>
-            <a:pPr marL="0" indent="0" algn="l">
-              <a:buNone/>
-            </a:pPr>
-            <a:r>
-              <a:rPr lang="en-US" sz="1100" dirty="0">
-                <a:solidFill>
-                  <a:srgbClr val="4A5568"/>
-                </a:solidFill>
-                <a:latin typeface="Calibri" pitchFamily="34" charset="0"/>
-                <a:ea typeface="Calibri" pitchFamily="34" charset="-122"/>
-                <a:cs typeface="Calibri" pitchFamily="34" charset="-120"/>
-              </a:rPr>
-              <a:t>標準化 ROI 作為分類輸入</a:t>
-            </a:r>
-            <a:endParaRPr lang="en-US" sz="1100" dirty="0"/>
-          </a:p>
-        </p:txBody>
-      </p:sp>
+      <p:pic>
+        <p:nvPicPr>
+          <p:cNvPr id="49" name="圖片 48">
+            <a:extLst>
+              <a:ext uri="{FF2B5EF4-FFF2-40B4-BE49-F238E27FC236}">
+                <a16:creationId xmlns:a16="http://schemas.microsoft.com/office/drawing/2014/main" id="{8B61B3B2-380E-FA89-DD31-1FECE48E6F52}"/>
+              </a:ext>
+            </a:extLst>
+          </p:cNvPr>
+          <p:cNvPicPr>
+            <a:picLocks noChangeAspect="1"/>
+          </p:cNvPicPr>
+          <p:nvPr/>
+        </p:nvPicPr>
+        <p:blipFill>
+          <a:blip r:embed="rId3"/>
+          <a:stretch>
+            <a:fillRect/>
+          </a:stretch>
+        </p:blipFill>
+        <p:spPr>
+          <a:xfrm>
+            <a:off x="1324355" y="2688336"/>
+            <a:ext cx="2252474" cy="1064161"/>
+          </a:xfrm>
+          <a:prstGeom prst="rect">
+            <a:avLst/>
+          </a:prstGeom>
+        </p:spPr>
+      </p:pic>
     </p:spTree>
   </p:cSld>
   <p:clrMapOvr>
@@ -19961,6 +19678,216 @@
           </a:p>
         </p:txBody>
       </p:sp>
+      <p:pic>
+        <p:nvPicPr>
+          <p:cNvPr id="31" name="圖片 30">
+            <a:extLst>
+              <a:ext uri="{FF2B5EF4-FFF2-40B4-BE49-F238E27FC236}">
+                <a16:creationId xmlns:a16="http://schemas.microsoft.com/office/drawing/2014/main" id="{FA172A94-BE30-DCA8-1BC2-1622D397FB91}"/>
+              </a:ext>
+            </a:extLst>
+          </p:cNvPr>
+          <p:cNvPicPr>
+            <a:picLocks noChangeAspect="1"/>
+          </p:cNvPicPr>
+          <p:nvPr/>
+        </p:nvPicPr>
+        <p:blipFill>
+          <a:blip r:embed="rId2"/>
+          <a:stretch>
+            <a:fillRect/>
+          </a:stretch>
+        </p:blipFill>
+        <p:spPr>
+          <a:xfrm>
+            <a:off x="1676754" y="3500631"/>
+            <a:ext cx="707740" cy="922683"/>
+          </a:xfrm>
+          <a:prstGeom prst="rect">
+            <a:avLst/>
+          </a:prstGeom>
+        </p:spPr>
+      </p:pic>
+      <p:pic>
+        <p:nvPicPr>
+          <p:cNvPr id="32" name="圖片 31">
+            <a:extLst>
+              <a:ext uri="{FF2B5EF4-FFF2-40B4-BE49-F238E27FC236}">
+                <a16:creationId xmlns:a16="http://schemas.microsoft.com/office/drawing/2014/main" id="{7ADE3407-5B25-8D84-B5C6-0ABC7ED15A6E}"/>
+              </a:ext>
+            </a:extLst>
+          </p:cNvPr>
+          <p:cNvPicPr>
+            <a:picLocks noChangeAspect="1"/>
+          </p:cNvPicPr>
+          <p:nvPr/>
+        </p:nvPicPr>
+        <p:blipFill>
+          <a:blip r:embed="rId3"/>
+          <a:stretch>
+            <a:fillRect/>
+          </a:stretch>
+        </p:blipFill>
+        <p:spPr>
+          <a:xfrm flipH="1">
+            <a:off x="635867" y="3500631"/>
+            <a:ext cx="705951" cy="925769"/>
+          </a:xfrm>
+          <a:prstGeom prst="rect">
+            <a:avLst/>
+          </a:prstGeom>
+        </p:spPr>
+      </p:pic>
+      <p:cxnSp>
+        <p:nvCxnSpPr>
+          <p:cNvPr id="36" name="直線單箭頭接點 35">
+            <a:extLst>
+              <a:ext uri="{FF2B5EF4-FFF2-40B4-BE49-F238E27FC236}">
+                <a16:creationId xmlns:a16="http://schemas.microsoft.com/office/drawing/2014/main" id="{DD71DDA5-5766-4359-3EEC-03669808D1D0}"/>
+              </a:ext>
+            </a:extLst>
+          </p:cNvPr>
+          <p:cNvCxnSpPr>
+            <a:stCxn id="32" idx="1"/>
+            <a:endCxn id="31" idx="1"/>
+          </p:cNvCxnSpPr>
+          <p:nvPr/>
+        </p:nvCxnSpPr>
+        <p:spPr>
+          <a:xfrm flipV="1">
+            <a:off x="1341818" y="3961973"/>
+            <a:ext cx="334936" cy="1543"/>
+          </a:xfrm>
+          <a:prstGeom prst="straightConnector1">
+            <a:avLst/>
+          </a:prstGeom>
+          <a:ln>
+            <a:tailEnd type="triangle"/>
+          </a:ln>
+        </p:spPr>
+        <p:style>
+          <a:lnRef idx="1">
+            <a:schemeClr val="dk1"/>
+          </a:lnRef>
+          <a:fillRef idx="0">
+            <a:schemeClr val="dk1"/>
+          </a:fillRef>
+          <a:effectRef idx="0">
+            <a:schemeClr val="dk1"/>
+          </a:effectRef>
+          <a:fontRef idx="minor">
+            <a:schemeClr val="tx1"/>
+          </a:fontRef>
+        </p:style>
+      </p:cxnSp>
+      <p:pic>
+        <p:nvPicPr>
+          <p:cNvPr id="38" name="圖片 37">
+            <a:extLst>
+              <a:ext uri="{FF2B5EF4-FFF2-40B4-BE49-F238E27FC236}">
+                <a16:creationId xmlns:a16="http://schemas.microsoft.com/office/drawing/2014/main" id="{767409BE-9C6E-6A33-A266-36FB5033B35F}"/>
+              </a:ext>
+            </a:extLst>
+          </p:cNvPr>
+          <p:cNvPicPr>
+            <a:picLocks noChangeAspect="1"/>
+          </p:cNvPicPr>
+          <p:nvPr/>
+        </p:nvPicPr>
+        <p:blipFill>
+          <a:blip r:embed="rId4"/>
+          <a:stretch>
+            <a:fillRect/>
+          </a:stretch>
+        </p:blipFill>
+        <p:spPr>
+          <a:xfrm>
+            <a:off x="2723040" y="3500631"/>
+            <a:ext cx="707740" cy="917441"/>
+          </a:xfrm>
+          <a:prstGeom prst="rect">
+            <a:avLst/>
+          </a:prstGeom>
+        </p:spPr>
+      </p:pic>
+      <p:sp>
+        <p:nvSpPr>
+          <p:cNvPr id="39" name="文字方塊 38">
+            <a:extLst>
+              <a:ext uri="{FF2B5EF4-FFF2-40B4-BE49-F238E27FC236}">
+                <a16:creationId xmlns:a16="http://schemas.microsoft.com/office/drawing/2014/main" id="{8E03BE90-9E4A-4D72-2605-E470D3EBC547}"/>
+              </a:ext>
+            </a:extLst>
+          </p:cNvPr>
+          <p:cNvSpPr txBox="1"/>
+          <p:nvPr/>
+        </p:nvSpPr>
+        <p:spPr>
+          <a:xfrm>
+            <a:off x="3765716" y="3834233"/>
+            <a:ext cx="476631" cy="269304"/>
+          </a:xfrm>
+          <a:prstGeom prst="rect">
+            <a:avLst/>
+          </a:prstGeom>
+          <a:noFill/>
+        </p:spPr>
+        <p:txBody>
+          <a:bodyPr wrap="square" rtlCol="0">
+            <a:spAutoFit/>
+          </a:bodyPr>
+          <a:lstStyle/>
+          <a:p>
+            <a:r>
+              <a:rPr lang="zh-TW" altLang="en-US" sz="1150" dirty="0"/>
+              <a:t>不變</a:t>
+            </a:r>
+          </a:p>
+        </p:txBody>
+      </p:sp>
+      <p:cxnSp>
+        <p:nvCxnSpPr>
+          <p:cNvPr id="41" name="直線單箭頭接點 40">
+            <a:extLst>
+              <a:ext uri="{FF2B5EF4-FFF2-40B4-BE49-F238E27FC236}">
+                <a16:creationId xmlns:a16="http://schemas.microsoft.com/office/drawing/2014/main" id="{7E2C412F-195D-E135-7852-DB866CD376C0}"/>
+              </a:ext>
+            </a:extLst>
+          </p:cNvPr>
+          <p:cNvCxnSpPr>
+            <a:cxnSpLocks/>
+            <a:stCxn id="38" idx="3"/>
+            <a:endCxn id="39" idx="1"/>
+          </p:cNvCxnSpPr>
+          <p:nvPr/>
+        </p:nvCxnSpPr>
+        <p:spPr>
+          <a:xfrm>
+            <a:off x="3430780" y="3959352"/>
+            <a:ext cx="334936" cy="9533"/>
+          </a:xfrm>
+          <a:prstGeom prst="straightConnector1">
+            <a:avLst/>
+          </a:prstGeom>
+          <a:ln>
+            <a:tailEnd type="triangle"/>
+          </a:ln>
+        </p:spPr>
+        <p:style>
+          <a:lnRef idx="1">
+            <a:schemeClr val="dk1"/>
+          </a:lnRef>
+          <a:fillRef idx="0">
+            <a:schemeClr val="dk1"/>
+          </a:fillRef>
+          <a:effectRef idx="0">
+            <a:schemeClr val="dk1"/>
+          </a:effectRef>
+          <a:fontRef idx="minor">
+            <a:schemeClr val="tx1"/>
+          </a:fontRef>
+        </p:style>
+      </p:cxnSp>
     </p:spTree>
   </p:cSld>
   <p:clrMapOvr>
@@ -22504,8 +22431,8 @@
           </a:p>
         </p:txBody>
       </p:sp>
-      <mc:AlternateContent xmlns:mc="http://schemas.openxmlformats.org/markup-compatibility/2006">
-        <mc:Choice xmlns:a14="http://schemas.microsoft.com/office/drawing/2010/main" Requires="a14">
+      <mc:AlternateContent xmlns:mc="http://schemas.openxmlformats.org/markup-compatibility/2006" xmlns:a14="http://schemas.microsoft.com/office/drawing/2010/main">
+        <mc:Choice Requires="a14">
           <p:sp>
             <p:nvSpPr>
               <p:cNvPr id="28" name="文字方塊 27">
@@ -22520,8 +22447,8 @@
             </p:nvSpPr>
             <p:spPr>
               <a:xfrm>
-                <a:off x="-800619" y="4151374"/>
-                <a:ext cx="6502421" cy="362215"/>
+                <a:off x="-850911" y="4533572"/>
+                <a:ext cx="6502421" cy="283539"/>
               </a:xfrm>
               <a:prstGeom prst="rect">
                 <a:avLst/>
@@ -22534,6 +22461,7 @@
               </a:bodyPr>
               <a:lstStyle/>
               <a:p>
+                <a:pPr/>
                 <a14:m>
                   <m:oMathPara xmlns:m="http://schemas.openxmlformats.org/officeDocument/2006/math">
                     <m:oMathParaPr>
@@ -22544,7 +22472,7 @@
                         <m:rPr>
                           <m:nor/>
                         </m:rPr>
-                        <a:rPr lang="en-US" altLang="zh-TW" sz="1150" i="0" smtClean="0">
+                        <a:rPr lang="en-US" altLang="zh-TW" sz="900" i="0" smtClean="0">
                           <a:latin typeface="Cambria Math" panose="02040503050406030204" pitchFamily="18" charset="0"/>
                         </a:rPr>
                         <m:t>Macro</m:t>
@@ -22553,7 +22481,7 @@
                         <m:rPr>
                           <m:nor/>
                         </m:rPr>
-                        <a:rPr lang="en-US" altLang="zh-TW" sz="1150" i="0" smtClean="0">
+                        <a:rPr lang="en-US" altLang="zh-TW" sz="900" i="0" smtClean="0">
                           <a:latin typeface="Cambria Math" panose="02040503050406030204" pitchFamily="18" charset="0"/>
                         </a:rPr>
                         <m:t> </m:t>
@@ -22562,7 +22490,7 @@
                         <m:rPr>
                           <m:nor/>
                         </m:rPr>
-                        <a:rPr lang="en-US" altLang="zh-TW" sz="1150" i="0" smtClean="0">
+                        <a:rPr lang="en-US" altLang="zh-TW" sz="900" i="0" smtClean="0">
                           <a:latin typeface="Cambria Math" panose="02040503050406030204" pitchFamily="18" charset="0"/>
                         </a:rPr>
                         <m:t>F</m:t>
@@ -22571,13 +22499,13 @@
                         <m:rPr>
                           <m:nor/>
                         </m:rPr>
-                        <a:rPr lang="en-US" altLang="zh-TW" sz="1150" i="0" smtClean="0">
+                        <a:rPr lang="en-US" altLang="zh-TW" sz="900" i="0" smtClean="0">
                           <a:latin typeface="Cambria Math" panose="02040503050406030204" pitchFamily="18" charset="0"/>
                         </a:rPr>
                         <m:t>1</m:t>
                       </m:r>
                       <m:r>
-                        <a:rPr lang="en-US" altLang="zh-TW" sz="1150" i="1" smtClean="0">
+                        <a:rPr lang="en-US" altLang="zh-TW" sz="900" i="1" smtClean="0">
                           <a:latin typeface="Cambria Math" panose="02040503050406030204" pitchFamily="18" charset="0"/>
                         </a:rPr>
                         <m:t> = </m:t>
@@ -22585,14 +22513,14 @@
                       <m:f>
                         <m:fPr>
                           <m:ctrlPr>
-                            <a:rPr lang="en-US" altLang="zh-TW" sz="1150" i="1" smtClean="0">
+                            <a:rPr lang="en-US" altLang="zh-TW" sz="900" i="1" smtClean="0">
                               <a:latin typeface="Cambria Math" panose="02040503050406030204" pitchFamily="18" charset="0"/>
                             </a:rPr>
                           </m:ctrlPr>
                         </m:fPr>
                         <m:num>
                           <m:r>
-                            <a:rPr lang="en-US" altLang="zh-TW" sz="1150" i="1" smtClean="0">
+                            <a:rPr lang="en-US" altLang="zh-TW" sz="900" i="1" smtClean="0">
                               <a:latin typeface="Cambria Math" panose="02040503050406030204" pitchFamily="18" charset="0"/>
                             </a:rPr>
                             <m:t>𝐹</m:t>
@@ -22600,14 +22528,14 @@
                           <m:sSub>
                             <m:sSubPr>
                               <m:ctrlPr>
-                                <a:rPr lang="en-US" altLang="zh-TW" sz="1150" i="1" smtClean="0">
+                                <a:rPr lang="en-US" altLang="zh-TW" sz="900" i="1" smtClean="0">
                                   <a:latin typeface="Cambria Math" panose="02040503050406030204" pitchFamily="18" charset="0"/>
                                 </a:rPr>
                               </m:ctrlPr>
                             </m:sSubPr>
                             <m:e>
                               <m:r>
-                                <a:rPr lang="en-US" altLang="zh-TW" sz="1150" i="1" smtClean="0">
+                                <a:rPr lang="en-US" altLang="zh-TW" sz="900" i="1" smtClean="0">
                                   <a:latin typeface="Cambria Math" panose="02040503050406030204" pitchFamily="18" charset="0"/>
                                 </a:rPr>
                                 <m:t>1</m:t>
@@ -22618,7 +22546,7 @@
                                 <m:rPr>
                                   <m:nor/>
                                 </m:rPr>
-                                <a:rPr lang="en-US" altLang="zh-TW" sz="1150" i="0" smtClean="0">
+                                <a:rPr lang="en-US" altLang="zh-TW" sz="900" i="0" smtClean="0">
                                   <a:latin typeface="Cambria Math" panose="02040503050406030204" pitchFamily="18" charset="0"/>
                                 </a:rPr>
                                 <m:t>Stage</m:t>
@@ -22627,30 +22555,21 @@
                                 <m:rPr>
                                   <m:nor/>
                                 </m:rPr>
-                                <a:rPr lang="en-US" altLang="zh-TW" sz="1150" i="0" smtClean="0">
+                                <a:rPr lang="en-US" altLang="zh-TW" sz="900" i="0" smtClean="0">
                                   <a:latin typeface="Cambria Math" panose="02040503050406030204" pitchFamily="18" charset="0"/>
                                 </a:rPr>
-                                <m:t> </m:t>
-                              </m:r>
-                              <m:r>
-                                <m:rPr>
-                                  <m:nor/>
-                                </m:rPr>
-                                <a:rPr lang="en-US" altLang="zh-TW" sz="1150" i="0" smtClean="0">
-                                  <a:latin typeface="Cambria Math" panose="02040503050406030204" pitchFamily="18" charset="0"/>
-                                </a:rPr>
-                                <m:t>1</m:t>
+                                <m:t> 1</m:t>
                               </m:r>
                             </m:sub>
                           </m:sSub>
                           <m:r>
-                            <a:rPr lang="en-US" altLang="zh-TW" sz="1150" i="1" smtClean="0">
+                            <a:rPr lang="en-US" altLang="zh-TW" sz="900" i="1" smtClean="0">
                               <a:latin typeface="Cambria Math" panose="02040503050406030204" pitchFamily="18" charset="0"/>
                             </a:rPr>
                             <m:t> + </m:t>
                           </m:r>
                           <m:r>
-                            <a:rPr lang="en-US" altLang="zh-TW" sz="1150" i="1" smtClean="0">
+                            <a:rPr lang="en-US" altLang="zh-TW" sz="900" i="1" smtClean="0">
                               <a:latin typeface="Cambria Math" panose="02040503050406030204" pitchFamily="18" charset="0"/>
                             </a:rPr>
                             <m:t>𝐹</m:t>
@@ -22658,14 +22577,14 @@
                           <m:sSub>
                             <m:sSubPr>
                               <m:ctrlPr>
-                                <a:rPr lang="en-US" altLang="zh-TW" sz="1150" i="1" smtClean="0">
+                                <a:rPr lang="en-US" altLang="zh-TW" sz="900" i="1" smtClean="0">
                                   <a:latin typeface="Cambria Math" panose="02040503050406030204" pitchFamily="18" charset="0"/>
                                 </a:rPr>
                               </m:ctrlPr>
                             </m:sSubPr>
                             <m:e>
                               <m:r>
-                                <a:rPr lang="en-US" altLang="zh-TW" sz="1150" i="1" smtClean="0">
+                                <a:rPr lang="en-US" altLang="zh-TW" sz="900" i="1" smtClean="0">
                                   <a:latin typeface="Cambria Math" panose="02040503050406030204" pitchFamily="18" charset="0"/>
                                 </a:rPr>
                                 <m:t>1</m:t>
@@ -22676,7 +22595,7 @@
                                 <m:rPr>
                                   <m:nor/>
                                 </m:rPr>
-                                <a:rPr lang="en-US" altLang="zh-TW" sz="1150" i="0" smtClean="0">
+                                <a:rPr lang="en-US" altLang="zh-TW" sz="900" i="0" smtClean="0">
                                   <a:latin typeface="Cambria Math" panose="02040503050406030204" pitchFamily="18" charset="0"/>
                                 </a:rPr>
                                 <m:t>Stage</m:t>
@@ -22685,30 +22604,21 @@
                                 <m:rPr>
                                   <m:nor/>
                                 </m:rPr>
-                                <a:rPr lang="en-US" altLang="zh-TW" sz="1150" i="0" smtClean="0">
+                                <a:rPr lang="en-US" altLang="zh-TW" sz="900" i="0" smtClean="0">
                                   <a:latin typeface="Cambria Math" panose="02040503050406030204" pitchFamily="18" charset="0"/>
                                 </a:rPr>
-                                <m:t> </m:t>
-                              </m:r>
-                              <m:r>
-                                <m:rPr>
-                                  <m:nor/>
-                                </m:rPr>
-                                <a:rPr lang="en-US" altLang="zh-TW" sz="1150" i="0" smtClean="0">
-                                  <a:latin typeface="Cambria Math" panose="02040503050406030204" pitchFamily="18" charset="0"/>
-                                </a:rPr>
-                                <m:t>2</m:t>
+                                <m:t> 2</m:t>
                               </m:r>
                             </m:sub>
                           </m:sSub>
                           <m:r>
-                            <a:rPr lang="en-US" altLang="zh-TW" sz="1150" i="1" smtClean="0">
+                            <a:rPr lang="en-US" altLang="zh-TW" sz="900" i="1" smtClean="0">
                               <a:latin typeface="Cambria Math" panose="02040503050406030204" pitchFamily="18" charset="0"/>
                             </a:rPr>
                             <m:t> + </m:t>
                           </m:r>
                           <m:r>
-                            <a:rPr lang="en-US" altLang="zh-TW" sz="1150" i="1" smtClean="0">
+                            <a:rPr lang="en-US" altLang="zh-TW" sz="900" i="1" smtClean="0">
                               <a:latin typeface="Cambria Math" panose="02040503050406030204" pitchFamily="18" charset="0"/>
                             </a:rPr>
                             <m:t>𝐹</m:t>
@@ -22716,14 +22626,14 @@
                           <m:sSub>
                             <m:sSubPr>
                               <m:ctrlPr>
-                                <a:rPr lang="en-US" altLang="zh-TW" sz="1150" i="1" smtClean="0">
+                                <a:rPr lang="en-US" altLang="zh-TW" sz="900" i="1" smtClean="0">
                                   <a:latin typeface="Cambria Math" panose="02040503050406030204" pitchFamily="18" charset="0"/>
                                 </a:rPr>
                               </m:ctrlPr>
                             </m:sSubPr>
                             <m:e>
                               <m:r>
-                                <a:rPr lang="en-US" altLang="zh-TW" sz="1150" i="1" smtClean="0">
+                                <a:rPr lang="en-US" altLang="zh-TW" sz="900" i="1" smtClean="0">
                                   <a:latin typeface="Cambria Math" panose="02040503050406030204" pitchFamily="18" charset="0"/>
                                 </a:rPr>
                                 <m:t>1</m:t>
@@ -22734,7 +22644,7 @@
                                 <m:rPr>
                                   <m:nor/>
                                 </m:rPr>
-                                <a:rPr lang="en-US" altLang="zh-TW" sz="1150" i="0" smtClean="0">
+                                <a:rPr lang="en-US" altLang="zh-TW" sz="900" i="0" smtClean="0">
                                   <a:latin typeface="Cambria Math" panose="02040503050406030204" pitchFamily="18" charset="0"/>
                                 </a:rPr>
                                 <m:t>Stage</m:t>
@@ -22743,30 +22653,21 @@
                                 <m:rPr>
                                   <m:nor/>
                                 </m:rPr>
-                                <a:rPr lang="en-US" altLang="zh-TW" sz="1150" i="0" smtClean="0">
+                                <a:rPr lang="en-US" altLang="zh-TW" sz="900" i="0" smtClean="0">
                                   <a:latin typeface="Cambria Math" panose="02040503050406030204" pitchFamily="18" charset="0"/>
                                 </a:rPr>
-                                <m:t> </m:t>
-                              </m:r>
-                              <m:r>
-                                <m:rPr>
-                                  <m:nor/>
-                                </m:rPr>
-                                <a:rPr lang="en-US" altLang="zh-TW" sz="1150" i="0" smtClean="0">
-                                  <a:latin typeface="Cambria Math" panose="02040503050406030204" pitchFamily="18" charset="0"/>
-                                </a:rPr>
-                                <m:t>3</m:t>
+                                <m:t> 3</m:t>
                               </m:r>
                             </m:sub>
                           </m:sSub>
                           <m:r>
-                            <a:rPr lang="en-US" altLang="zh-TW" sz="1150" i="1" smtClean="0">
+                            <a:rPr lang="en-US" altLang="zh-TW" sz="900" i="1" smtClean="0">
                               <a:latin typeface="Cambria Math" panose="02040503050406030204" pitchFamily="18" charset="0"/>
                             </a:rPr>
                             <m:t> + </m:t>
                           </m:r>
                           <m:r>
-                            <a:rPr lang="en-US" altLang="zh-TW" sz="1150" i="1" smtClean="0">
+                            <a:rPr lang="en-US" altLang="zh-TW" sz="900" i="1" smtClean="0">
                               <a:latin typeface="Cambria Math" panose="02040503050406030204" pitchFamily="18" charset="0"/>
                             </a:rPr>
                             <m:t>𝐹</m:t>
@@ -22774,14 +22675,14 @@
                           <m:sSub>
                             <m:sSubPr>
                               <m:ctrlPr>
-                                <a:rPr lang="en-US" altLang="zh-TW" sz="1150" i="1" smtClean="0">
+                                <a:rPr lang="en-US" altLang="zh-TW" sz="900" i="1" smtClean="0">
                                   <a:latin typeface="Cambria Math" panose="02040503050406030204" pitchFamily="18" charset="0"/>
                                 </a:rPr>
                               </m:ctrlPr>
                             </m:sSubPr>
                             <m:e>
                               <m:r>
-                                <a:rPr lang="en-US" altLang="zh-TW" sz="1150" i="1" smtClean="0">
+                                <a:rPr lang="en-US" altLang="zh-TW" sz="900" i="1" smtClean="0">
                                   <a:latin typeface="Cambria Math" panose="02040503050406030204" pitchFamily="18" charset="0"/>
                                 </a:rPr>
                                 <m:t>1</m:t>
@@ -22792,7 +22693,7 @@
                                 <m:rPr>
                                   <m:nor/>
                                 </m:rPr>
-                                <a:rPr lang="en-US" altLang="zh-TW" sz="1150" i="0" smtClean="0">
+                                <a:rPr lang="en-US" altLang="zh-TW" sz="900" i="0" smtClean="0">
                                   <a:latin typeface="Cambria Math" panose="02040503050406030204" pitchFamily="18" charset="0"/>
                                 </a:rPr>
                                 <m:t>Stage</m:t>
@@ -22801,26 +22702,17 @@
                                 <m:rPr>
                                   <m:nor/>
                                 </m:rPr>
-                                <a:rPr lang="en-US" altLang="zh-TW" sz="1150" i="0" smtClean="0">
+                                <a:rPr lang="en-US" altLang="zh-TW" sz="900" i="0" smtClean="0">
                                   <a:latin typeface="Cambria Math" panose="02040503050406030204" pitchFamily="18" charset="0"/>
                                 </a:rPr>
-                                <m:t> </m:t>
-                              </m:r>
-                              <m:r>
-                                <m:rPr>
-                                  <m:nor/>
-                                </m:rPr>
-                                <a:rPr lang="en-US" altLang="zh-TW" sz="1150" i="0" smtClean="0">
-                                  <a:latin typeface="Cambria Math" panose="02040503050406030204" pitchFamily="18" charset="0"/>
-                                </a:rPr>
-                                <m:t>4</m:t>
+                                <m:t> 4</m:t>
                               </m:r>
                             </m:sub>
                           </m:sSub>
                         </m:num>
                         <m:den>
                           <m:r>
-                            <a:rPr lang="en-US" altLang="zh-TW" sz="1150" i="1" smtClean="0">
+                            <a:rPr lang="en-US" altLang="zh-TW" sz="900" i="1" smtClean="0">
                               <a:latin typeface="Cambria Math" panose="02040503050406030204" pitchFamily="18" charset="0"/>
                             </a:rPr>
                             <m:t>4</m:t>
@@ -22830,12 +22722,12 @@
                     </m:oMath>
                   </m:oMathPara>
                 </a14:m>
-                <a:endParaRPr lang="zh-TW" altLang="en-US" sz="1150" dirty="0"/>
+                <a:endParaRPr lang="zh-TW" altLang="en-US" sz="900" dirty="0"/>
               </a:p>
             </p:txBody>
           </p:sp>
         </mc:Choice>
-        <mc:Fallback>
+        <mc:Fallback xmlns="">
           <p:sp>
             <p:nvSpPr>
               <p:cNvPr id="28" name="文字方塊 27">
@@ -22852,8 +22744,8 @@
             </p:nvSpPr>
             <p:spPr>
               <a:xfrm>
-                <a:off x="-800619" y="4151374"/>
-                <a:ext cx="6502421" cy="362215"/>
+                <a:off x="-850911" y="4533572"/>
+                <a:ext cx="6502421" cy="283539"/>
               </a:xfrm>
               <a:prstGeom prst="rect">
                 <a:avLst/>
@@ -22861,7 +22753,188 @@
               <a:blipFill>
                 <a:blip r:embed="rId2"/>
                 <a:stretch>
-                  <a:fillRect b="-13559"/>
+                  <a:fillRect t="-2174" b="-17391"/>
+                </a:stretch>
+              </a:blipFill>
+            </p:spPr>
+            <p:txBody>
+              <a:bodyPr/>
+              <a:lstStyle/>
+              <a:p>
+                <a:r>
+                  <a:rPr lang="zh-TW" altLang="en-US">
+                    <a:noFill/>
+                  </a:rPr>
+                  <a:t> </a:t>
+                </a:r>
+              </a:p>
+            </p:txBody>
+          </p:sp>
+        </mc:Fallback>
+      </mc:AlternateContent>
+      <mc:AlternateContent xmlns:mc="http://schemas.openxmlformats.org/markup-compatibility/2006" xmlns:a14="http://schemas.microsoft.com/office/drawing/2010/main">
+        <mc:Choice Requires="a14">
+          <p:sp>
+            <p:nvSpPr>
+              <p:cNvPr id="29" name="文字方塊 28">
+                <a:extLst>
+                  <a:ext uri="{FF2B5EF4-FFF2-40B4-BE49-F238E27FC236}">
+                    <a16:creationId xmlns:a16="http://schemas.microsoft.com/office/drawing/2014/main" id="{81F4CFB1-A0CE-6BA4-54F0-7826275B27CA}"/>
+                  </a:ext>
+                </a:extLst>
+              </p:cNvPr>
+              <p:cNvSpPr txBox="1"/>
+              <p:nvPr/>
+            </p:nvSpPr>
+            <p:spPr>
+              <a:xfrm>
+                <a:off x="1701389" y="4000422"/>
+                <a:ext cx="1397819" cy="265329"/>
+              </a:xfrm>
+              <a:prstGeom prst="rect">
+                <a:avLst/>
+              </a:prstGeom>
+              <a:noFill/>
+            </p:spPr>
+            <p:txBody>
+              <a:bodyPr wrap="none" lIns="0" tIns="0" rIns="0" bIns="0" rtlCol="0">
+                <a:spAutoFit/>
+              </a:bodyPr>
+              <a:lstStyle/>
+              <a:p>
+                <a:pPr/>
+                <a14:m>
+                  <m:oMathPara xmlns:m="http://schemas.openxmlformats.org/officeDocument/2006/math">
+                    <m:oMathParaPr>
+                      <m:jc m:val="centerGroup"/>
+                    </m:oMathParaPr>
+                    <m:oMath xmlns:m="http://schemas.openxmlformats.org/officeDocument/2006/math">
+                      <m:r>
+                        <m:rPr>
+                          <m:nor/>
+                        </m:rPr>
+                        <a:rPr lang="en-US" altLang="zh-TW" sz="900" i="0" smtClean="0">
+                          <a:latin typeface="Cambria Math" panose="02040503050406030204" pitchFamily="18" charset="0"/>
+                        </a:rPr>
+                        <m:t>F</m:t>
+                      </m:r>
+                      <m:r>
+                        <m:rPr>
+                          <m:nor/>
+                        </m:rPr>
+                        <a:rPr lang="en-US" altLang="zh-TW" sz="900" smtClean="0">
+                          <a:latin typeface="Cambria Math" panose="02040503050406030204" pitchFamily="18" charset="0"/>
+                        </a:rPr>
+                        <m:t>1</m:t>
+                      </m:r>
+                      <m:r>
+                        <a:rPr lang="en-US" altLang="zh-TW" sz="900">
+                          <a:latin typeface="Cambria Math" panose="02040503050406030204" pitchFamily="18" charset="0"/>
+                        </a:rPr>
+                        <m:t>=2</m:t>
+                      </m:r>
+                      <m:r>
+                        <a:rPr lang="en-US" altLang="zh-TW" sz="900" i="1">
+                          <a:latin typeface="Cambria Math" panose="02040503050406030204" pitchFamily="18" charset="0"/>
+                        </a:rPr>
+                        <m:t>×</m:t>
+                      </m:r>
+                      <m:f>
+                        <m:fPr>
+                          <m:ctrlPr>
+                            <a:rPr lang="en-US" altLang="zh-TW" sz="900" i="1">
+                              <a:latin typeface="Cambria Math" panose="02040503050406030204" pitchFamily="18" charset="0"/>
+                            </a:rPr>
+                          </m:ctrlPr>
+                        </m:fPr>
+                        <m:num>
+                          <m:r>
+                            <m:rPr>
+                              <m:nor/>
+                            </m:rPr>
+                            <a:rPr lang="en-US" altLang="zh-TW" sz="900" i="0">
+                              <a:latin typeface="Cambria Math" panose="02040503050406030204" pitchFamily="18" charset="0"/>
+                            </a:rPr>
+                            <m:t>Precision</m:t>
+                          </m:r>
+                          <m:r>
+                            <a:rPr lang="en-US" altLang="zh-TW" sz="900" i="1">
+                              <a:latin typeface="Cambria Math" panose="02040503050406030204" pitchFamily="18" charset="0"/>
+                            </a:rPr>
+                            <m:t>×</m:t>
+                          </m:r>
+                          <m:r>
+                            <m:rPr>
+                              <m:nor/>
+                            </m:rPr>
+                            <a:rPr lang="en-US" altLang="zh-TW" sz="900" i="0">
+                              <a:latin typeface="Cambria Math" panose="02040503050406030204" pitchFamily="18" charset="0"/>
+                            </a:rPr>
+                            <m:t>Recall</m:t>
+                          </m:r>
+                        </m:num>
+                        <m:den>
+                          <m:r>
+                            <m:rPr>
+                              <m:nor/>
+                            </m:rPr>
+                            <a:rPr lang="en-US" altLang="zh-TW" sz="900" i="0">
+                              <a:latin typeface="Cambria Math" panose="02040503050406030204" pitchFamily="18" charset="0"/>
+                            </a:rPr>
+                            <m:t>Precision</m:t>
+                          </m:r>
+                          <m:r>
+                            <a:rPr lang="en-US" altLang="zh-TW" sz="900">
+                              <a:latin typeface="Cambria Math" panose="02040503050406030204" pitchFamily="18" charset="0"/>
+                            </a:rPr>
+                            <m:t>+</m:t>
+                          </m:r>
+                          <m:r>
+                            <m:rPr>
+                              <m:nor/>
+                            </m:rPr>
+                            <a:rPr lang="en-US" altLang="zh-TW" sz="900" i="0">
+                              <a:latin typeface="Cambria Math" panose="02040503050406030204" pitchFamily="18" charset="0"/>
+                            </a:rPr>
+                            <m:t>Recall</m:t>
+                          </m:r>
+                        </m:den>
+                      </m:f>
+                    </m:oMath>
+                  </m:oMathPara>
+                </a14:m>
+                <a:endParaRPr lang="zh-TW" altLang="en-US" sz="900" dirty="0"/>
+              </a:p>
+            </p:txBody>
+          </p:sp>
+        </mc:Choice>
+        <mc:Fallback xmlns="">
+          <p:sp>
+            <p:nvSpPr>
+              <p:cNvPr id="29" name="文字方塊 28">
+                <a:extLst>
+                  <a:ext uri="{FF2B5EF4-FFF2-40B4-BE49-F238E27FC236}">
+                    <a16:creationId xmlns:a16="http://schemas.microsoft.com/office/drawing/2014/main" id="{81F4CFB1-A0CE-6BA4-54F0-7826275B27CA}"/>
+                  </a:ext>
+                </a:extLst>
+              </p:cNvPr>
+              <p:cNvSpPr txBox="1">
+                <a:spLocks noRot="1" noChangeAspect="1" noMove="1" noResize="1" noEditPoints="1" noAdjustHandles="1" noChangeArrowheads="1" noChangeShapeType="1" noTextEdit="1"/>
+              </p:cNvSpPr>
+              <p:nvPr/>
+            </p:nvSpPr>
+            <p:spPr>
+              <a:xfrm>
+                <a:off x="1701389" y="4000422"/>
+                <a:ext cx="1397819" cy="265329"/>
+              </a:xfrm>
+              <a:prstGeom prst="rect">
+                <a:avLst/>
+              </a:prstGeom>
+              <a:blipFill>
+                <a:blip r:embed="rId3"/>
+                <a:stretch>
+                  <a:fillRect l="-1747" t="-2273" r="-1310" b="-13636"/>
                 </a:stretch>
               </a:blipFill>
             </p:spPr>
@@ -23380,9 +23453,6 @@
             </a:r>
           </a:p>
           <a:p>
-            <a:pPr marL="0" indent="0" algn="l">
-              <a:buNone/>
-            </a:pPr>
             <a:r>
               <a:rPr lang="zh-TW" sz="950" b="0" dirty="0">
                 <a:solidFill>
@@ -23390,7 +23460,43 @@
                 </a:solidFill>
                 <a:latin typeface="Calibri" pitchFamily="34" charset="0"/>
               </a:rPr>
-              <a:t>DenseNet 家族 + EfficientNet 家族 + ResNet 家族</a:t>
+              <a:t>DenseNet 家族 + </a:t>
+            </a:r>
+            <a:r>
+              <a:rPr lang="zh-TW" altLang="zh-TW" sz="950" dirty="0">
+                <a:solidFill>
+                  <a:srgbClr val="4A5568"/>
+                </a:solidFill>
+                <a:latin typeface="Calibri" pitchFamily="34" charset="0"/>
+              </a:rPr>
+              <a:t>ConvNeXt</a:t>
+            </a:r>
+            <a:r>
+              <a:rPr lang="zh-TW" sz="950" b="0" dirty="0">
+                <a:solidFill>
+                  <a:srgbClr val="4A5568"/>
+                </a:solidFill>
+                <a:latin typeface="Calibri" pitchFamily="34" charset="0"/>
+              </a:rPr>
+              <a:t> 家族 + </a:t>
+            </a:r>
+            <a:r>
+              <a:rPr lang="zh-TW" altLang="zh-TW" sz="950" dirty="0">
+                <a:solidFill>
+                  <a:srgbClr val="4A5568"/>
+                </a:solidFill>
+                <a:latin typeface="Calibri" pitchFamily="34" charset="0"/>
+              </a:rPr>
+              <a:t>EfficientNet</a:t>
+            </a:r>
+            <a:r>
+              <a:rPr lang="zh-TW" sz="950" b="0" dirty="0">
+                <a:solidFill>
+                  <a:srgbClr val="4A5568"/>
+                </a:solidFill>
+                <a:latin typeface="Calibri" pitchFamily="34" charset="0"/>
+              </a:rPr>
+              <a:t>家族</a:t>
             </a:r>
           </a:p>
         </p:txBody>

</xml_diff>